<commit_message>
Typeset PowerPoint equations with LaTeX; link the live deck in README
- deck/data/make_eqs.py renders the nine display equations to transparent
  PNGs (deck/data/eq/); build_pptx.py places them in shaded panels
- real sub/superscripts for inline symbols in the PowerPoint text
- README links the GitHub Pages deck and documents the equation build

Co-Authored-By: Claude Opus 5.5 <noreply@anthropic.com>
</commit_message>
<xml_diff>
--- a/Moen_ICCFSS_2026_rack_standards.pptx
+++ b/Moen_ICCFSS_2026_rack_standards.pptx
@@ -4082,7 +4082,43 @@
             </a:pPr>
             <a:r>
               <a:rPr b="0" sz="1400"/>
-              <a:t>Ni = 0.004 αYi with the stiffness reduction τb, or 0.005 αYi without; minimum 0.002 αYi</a:t>
+              <a:t>N</a:t>
+            </a:r>
+            <a:r>
+              <a:rPr baseline="-25000" b="0" sz="1400"/>
+              <a:t>i</a:t>
+            </a:r>
+            <a:r>
+              <a:rPr b="0" sz="1400"/>
+              <a:t> = 0.004 αY</a:t>
+            </a:r>
+            <a:r>
+              <a:rPr baseline="-25000" b="0" sz="1400"/>
+              <a:t>i</a:t>
+            </a:r>
+            <a:r>
+              <a:rPr b="0" sz="1400"/>
+              <a:t> with the stiffness reduction τ</a:t>
+            </a:r>
+            <a:r>
+              <a:rPr baseline="-25000" b="0" sz="1400"/>
+              <a:t>b</a:t>
+            </a:r>
+            <a:r>
+              <a:rPr b="0" sz="1400"/>
+              <a:t>, or 0.005 αY</a:t>
+            </a:r>
+            <a:r>
+              <a:rPr baseline="-25000" b="0" sz="1400"/>
+              <a:t>i</a:t>
+            </a:r>
+            <a:r>
+              <a:rPr b="0" sz="1400"/>
+              <a:t> without; minimum 0.002 αY</a:t>
+            </a:r>
+            <a:r>
+              <a:rPr baseline="-25000" b="0" sz="1400"/>
+              <a:t>i</a:t>
             </a:r>
           </a:p>
           <a:p>
@@ -4093,7 +4129,31 @@
             </a:pPr>
             <a:r>
               <a:rPr b="0" sz="1400"/>
-              <a:t>B2 = 1 / (1 − α PΔ / (Rm H L))</a:t>
+              <a:t>B</a:t>
+            </a:r>
+            <a:r>
+              <a:rPr baseline="-25000" b="0" sz="1400"/>
+              <a:t>2</a:t>
+            </a:r>
+            <a:r>
+              <a:rPr b="0" sz="1400"/>
+              <a:t> = 1 / (1 − α P</a:t>
+            </a:r>
+            <a:r>
+              <a:rPr baseline="-25000" b="0" sz="1400"/>
+              <a:t>Δ</a:t>
+            </a:r>
+            <a:r>
+              <a:rPr b="0" sz="1400"/>
+              <a:t> / (R</a:t>
+            </a:r>
+            <a:r>
+              <a:rPr baseline="-25000" b="0" sz="1400"/>
+              <a:t>m</a:t>
+            </a:r>
+            <a:r>
+              <a:rPr b="0" sz="1400"/>
+              <a:t> H L))</a:t>
             </a:r>
           </a:p>
           <a:p>
@@ -4115,7 +4175,15 @@
             </a:pPr>
             <a:r>
               <a:rPr b="0" sz="1600"/>
-              <a:t>Down-aisle Kx = 1.0 (§10.2.1)</a:t>
+              <a:t>Down-aisle K</a:t>
+            </a:r>
+            <a:r>
+              <a:rPr baseline="-25000" b="0" sz="1600"/>
+              <a:t>x</a:t>
+            </a:r>
+            <a:r>
+              <a:rPr b="0" sz="1600"/>
+              <a:t> = 1.0 (§10.2.1)</a:t>
             </a:r>
           </a:p>
           <a:p>
@@ -4157,7 +4225,19 @@
             </a:r>
             <a:r>
               <a:rPr b="0" sz="1600"/>
-              <a:t> (§13.5): design moment 0.75 Mmax; stiffness is the secant at 0.8 Mconn,d</a:t>
+              <a:t> (§13.5): design moment 0.75 M</a:t>
+            </a:r>
+            <a:r>
+              <a:rPr baseline="-25000" b="0" sz="1600"/>
+              <a:t>max</a:t>
+            </a:r>
+            <a:r>
+              <a:rPr b="0" sz="1600"/>
+              <a:t>; stiffness is the secant at 0.8 M</a:t>
+            </a:r>
+            <a:r>
+              <a:rPr baseline="-25000" b="0" sz="1600"/>
+              <a:t>conn,d</a:t>
             </a:r>
           </a:p>
           <a:p>
@@ -4680,7 +4760,7 @@
         <p:spPr>
           <a:xfrm>
             <a:off x="838200" y="1825625"/>
-            <a:ext cx="5181600" cy="3017520"/>
+            <a:ext cx="5181600" cy="2820924"/>
           </a:xfrm>
           <a:prstGeom prst="rect">
             <a:avLst/>
@@ -4710,14 +4790,35 @@
           </a:fontRef>
         </p:style>
         <p:txBody>
-          <a:bodyPr rtlCol="0" anchor="t" wrap="square" lIns="137160" rIns="137160" tIns="73152"/>
-          <a:lstStyle/>
-          <a:p>
-            <a:pPr algn="ctr">
-              <a:spcAft>
-                <a:spcPts val="600"/>
-              </a:spcAft>
-            </a:pPr>
+          <a:bodyPr rtlCol="0" anchor="ctr"/>
+          <a:lstStyle/>
+          <a:p>
+            <a:pPr algn="ctr"/>
+          </a:p>
+        </p:txBody>
+      </p:sp>
+      <p:sp>
+        <p:nvSpPr>
+          <p:cNvPr id="4" name="TextBox 3"/>
+          <p:cNvSpPr txBox="1"/>
+          <p:nvPr/>
+        </p:nvSpPr>
+        <p:spPr>
+          <a:xfrm>
+            <a:off x="883920" y="1880489"/>
+            <a:ext cx="5181600" cy="320040"/>
+          </a:xfrm>
+          <a:prstGeom prst="rect">
+            <a:avLst/>
+          </a:prstGeom>
+          <a:noFill/>
+        </p:spPr>
+        <p:txBody>
+          <a:bodyPr wrap="none">
+            <a:spAutoFit/>
+          </a:bodyPr>
+          <a:lstStyle/>
+          <a:p>
             <a:r>
               <a:rPr b="1" sz="1400">
                 <a:solidFill>
@@ -4727,34 +4828,158 @@
               <a:t>Compression (§4.1.3.1)</a:t>
             </a:r>
           </a:p>
-          <a:p>
-            <a:pPr>
-              <a:spcAft>
-                <a:spcPts val="400"/>
-              </a:spcAft>
-            </a:pPr>
+        </p:txBody>
+      </p:sp>
+      <p:sp>
+        <p:nvSpPr>
+          <p:cNvPr id="5" name="TextBox 4"/>
+          <p:cNvSpPr txBox="1"/>
+          <p:nvPr/>
+        </p:nvSpPr>
+        <p:spPr>
+          <a:xfrm>
+            <a:off x="883920" y="2282825"/>
+            <a:ext cx="5090160" cy="228600"/>
+          </a:xfrm>
+          <a:prstGeom prst="rect">
+            <a:avLst/>
+          </a:prstGeom>
+          <a:noFill/>
+        </p:spPr>
+        <p:txBody>
+          <a:bodyPr wrap="square" tIns="0" bIns="0">
+            <a:spAutoFit/>
+          </a:bodyPr>
+          <a:lstStyle/>
+          <a:p>
             <a:r>
               <a:rPr b="0" sz="1500">
                 <a:solidFill>
                   <a:srgbClr val="2B3648"/>
                 </a:solidFill>
               </a:rPr>
-              <a:t>Ae = [1 − (1 − Q)(Fn / Fy)^Q] · Anet,min</a:t>
-            </a:r>
-          </a:p>
-          <a:p>
-            <a:pPr>
-              <a:spcAft>
-                <a:spcPts val="400"/>
-              </a:spcAft>
-            </a:pPr>
+              <a:t>•  Effective area from the stub-column test:</a:t>
+            </a:r>
+          </a:p>
+        </p:txBody>
+      </p:sp>
+      <p:pic>
+        <p:nvPicPr>
+          <p:cNvPr id="6" name="Picture 5" descr="ae.png"/>
+          <p:cNvPicPr>
+            <a:picLocks noChangeAspect="1"/>
+          </p:cNvPicPr>
+          <p:nvPr/>
+        </p:nvPicPr>
+        <p:blipFill>
+          <a:blip r:embed="rId2"/>
+          <a:stretch>
+            <a:fillRect/>
+          </a:stretch>
+        </p:blipFill>
+        <p:spPr>
+          <a:xfrm>
+            <a:off x="1021080" y="2602865"/>
+            <a:ext cx="3995928" cy="864108"/>
+          </a:xfrm>
+          <a:prstGeom prst="rect">
+            <a:avLst/>
+          </a:prstGeom>
+        </p:spPr>
+      </p:pic>
+      <p:sp>
+        <p:nvSpPr>
+          <p:cNvPr id="7" name="TextBox 6"/>
+          <p:cNvSpPr txBox="1"/>
+          <p:nvPr/>
+        </p:nvSpPr>
+        <p:spPr>
+          <a:xfrm>
+            <a:off x="883920" y="3540125"/>
+            <a:ext cx="5090160" cy="457200"/>
+          </a:xfrm>
+          <a:prstGeom prst="rect">
+            <a:avLst/>
+          </a:prstGeom>
+          <a:noFill/>
+        </p:spPr>
+        <p:txBody>
+          <a:bodyPr wrap="square" tIns="0" bIns="0">
+            <a:spAutoFit/>
+          </a:bodyPr>
+          <a:lstStyle/>
+          <a:p>
             <a:r>
               <a:rPr b="0" sz="1500">
                 <a:solidFill>
                   <a:srgbClr val="2B3648"/>
                 </a:solidFill>
               </a:rPr>
-              <a:t>Pn = Ae Fn, with Fn from AISI S100 on the </a:t>
+              <a:t>•  P</a:t>
+            </a:r>
+            <a:r>
+              <a:rPr baseline="-25000" b="0" sz="1500">
+                <a:solidFill>
+                  <a:srgbClr val="2B3648"/>
+                </a:solidFill>
+              </a:rPr>
+              <a:t>n</a:t>
+            </a:r>
+            <a:r>
+              <a:rPr b="0" sz="1500">
+                <a:solidFill>
+                  <a:srgbClr val="2B3648"/>
+                </a:solidFill>
+              </a:rPr>
+              <a:t> = A</a:t>
+            </a:r>
+            <a:r>
+              <a:rPr baseline="-25000" b="0" sz="1500">
+                <a:solidFill>
+                  <a:srgbClr val="2B3648"/>
+                </a:solidFill>
+              </a:rPr>
+              <a:t>e</a:t>
+            </a:r>
+            <a:r>
+              <a:rPr b="0" sz="1500">
+                <a:solidFill>
+                  <a:srgbClr val="2B3648"/>
+                </a:solidFill>
+              </a:rPr>
+              <a:t> F</a:t>
+            </a:r>
+            <a:r>
+              <a:rPr baseline="-25000" b="0" sz="1500">
+                <a:solidFill>
+                  <a:srgbClr val="2B3648"/>
+                </a:solidFill>
+              </a:rPr>
+              <a:t>n</a:t>
+            </a:r>
+            <a:r>
+              <a:rPr b="0" sz="1500">
+                <a:solidFill>
+                  <a:srgbClr val="2B3648"/>
+                </a:solidFill>
+              </a:rPr>
+              <a:t>, with F</a:t>
+            </a:r>
+            <a:r>
+              <a:rPr baseline="-25000" b="0" sz="1500">
+                <a:solidFill>
+                  <a:srgbClr val="2B3648"/>
+                </a:solidFill>
+              </a:rPr>
+              <a:t>n</a:t>
+            </a:r>
+            <a:r>
+              <a:rPr b="0" sz="1500">
+                <a:solidFill>
+                  <a:srgbClr val="2B3648"/>
+                </a:solidFill>
+              </a:rPr>
+              <a:t> from AISI S100 on the </a:t>
             </a:r>
             <a:r>
               <a:rPr b="1" sz="1500">
@@ -4773,33 +4998,83 @@
               <a:t> section</a:t>
             </a:r>
           </a:p>
-          <a:p>
-            <a:pPr>
-              <a:spcAft>
-                <a:spcPts val="400"/>
-              </a:spcAft>
-            </a:pPr>
+        </p:txBody>
+      </p:sp>
+      <p:sp>
+        <p:nvSpPr>
+          <p:cNvPr id="8" name="TextBox 7"/>
+          <p:cNvSpPr txBox="1"/>
+          <p:nvPr/>
+        </p:nvSpPr>
+        <p:spPr>
+          <a:xfrm>
+            <a:off x="883920" y="4070477"/>
+            <a:ext cx="5090160" cy="457200"/>
+          </a:xfrm>
+          <a:prstGeom prst="rect">
+            <a:avLst/>
+          </a:prstGeom>
+          <a:noFill/>
+        </p:spPr>
+        <p:txBody>
+          <a:bodyPr wrap="square" tIns="0" bIns="0">
+            <a:spAutoFit/>
+          </a:bodyPr>
+          <a:lstStyle/>
+          <a:p>
             <a:r>
               <a:rPr b="0" sz="1500">
                 <a:solidFill>
                   <a:srgbClr val="2B3648"/>
                 </a:solidFill>
               </a:rPr>
-              <a:t>Q = stub column strength / (Fy Anet,min) ≤ 1  (§9.2.2)</a:t>
-            </a:r>
-          </a:p>
-        </p:txBody>
-      </p:sp>
-      <p:sp>
-        <p:nvSpPr>
-          <p:cNvPr id="4" name="Rectangle 3"/>
+              <a:t>•  Q = stub column strength / (F</a:t>
+            </a:r>
+            <a:r>
+              <a:rPr baseline="-25000" b="0" sz="1500">
+                <a:solidFill>
+                  <a:srgbClr val="2B3648"/>
+                </a:solidFill>
+              </a:rPr>
+              <a:t>y</a:t>
+            </a:r>
+            <a:r>
+              <a:rPr b="0" sz="1500">
+                <a:solidFill>
+                  <a:srgbClr val="2B3648"/>
+                </a:solidFill>
+              </a:rPr>
+              <a:t> A</a:t>
+            </a:r>
+            <a:r>
+              <a:rPr baseline="-25000" b="0" sz="1500">
+                <a:solidFill>
+                  <a:srgbClr val="2B3648"/>
+                </a:solidFill>
+              </a:rPr>
+              <a:t>net,min</a:t>
+            </a:r>
+            <a:r>
+              <a:rPr b="0" sz="1500">
+                <a:solidFill>
+                  <a:srgbClr val="2B3648"/>
+                </a:solidFill>
+              </a:rPr>
+              <a:t>) ≤ 1  (§9.2.2)</a:t>
+            </a:r>
+          </a:p>
+        </p:txBody>
+      </p:sp>
+      <p:sp>
+        <p:nvSpPr>
+          <p:cNvPr id="9" name="Rectangle 8"/>
           <p:cNvSpPr/>
           <p:nvPr/>
         </p:nvSpPr>
         <p:spPr>
           <a:xfrm>
             <a:off x="6172200" y="1825625"/>
-            <a:ext cx="5181600" cy="1371600"/>
+            <a:ext cx="5181600" cy="1473708"/>
           </a:xfrm>
           <a:prstGeom prst="rect">
             <a:avLst/>
@@ -4829,14 +5104,35 @@
           </a:fontRef>
         </p:style>
         <p:txBody>
-          <a:bodyPr rtlCol="0" anchor="t" wrap="square" lIns="137160" rIns="137160" tIns="73152"/>
-          <a:lstStyle/>
-          <a:p>
-            <a:pPr algn="ctr">
-              <a:spcAft>
-                <a:spcPts val="600"/>
-              </a:spcAft>
-            </a:pPr>
+          <a:bodyPr rtlCol="0" anchor="ctr"/>
+          <a:lstStyle/>
+          <a:p>
+            <a:pPr algn="ctr"/>
+          </a:p>
+        </p:txBody>
+      </p:sp>
+      <p:sp>
+        <p:nvSpPr>
+          <p:cNvPr id="10" name="TextBox 9"/>
+          <p:cNvSpPr txBox="1"/>
+          <p:nvPr/>
+        </p:nvSpPr>
+        <p:spPr>
+          <a:xfrm>
+            <a:off x="6217920" y="1880489"/>
+            <a:ext cx="5181600" cy="320040"/>
+          </a:xfrm>
+          <a:prstGeom prst="rect">
+            <a:avLst/>
+          </a:prstGeom>
+          <a:noFill/>
+        </p:spPr>
+        <p:txBody>
+          <a:bodyPr wrap="none">
+            <a:spAutoFit/>
+          </a:bodyPr>
+          <a:lstStyle/>
+          <a:p>
             <a:r>
               <a:rPr b="1" sz="1400">
                 <a:solidFill>
@@ -4846,48 +5142,99 @@
               <a:t>Flexure (§4.1.2)</a:t>
             </a:r>
           </a:p>
-          <a:p>
-            <a:pPr>
-              <a:spcAft>
-                <a:spcPts val="400"/>
-              </a:spcAft>
-            </a:pPr>
+        </p:txBody>
+      </p:sp>
+      <p:pic>
+        <p:nvPicPr>
+          <p:cNvPr id="11" name="Picture 10" descr="se.png"/>
+          <p:cNvPicPr>
+            <a:picLocks noChangeAspect="1"/>
+          </p:cNvPicPr>
+          <p:nvPr/>
+        </p:nvPicPr>
+        <p:blipFill>
+          <a:blip r:embed="rId3"/>
+          <a:stretch>
+            <a:fillRect/>
+          </a:stretch>
+        </p:blipFill>
+        <p:spPr>
+          <a:xfrm>
+            <a:off x="6355080" y="2301113"/>
+            <a:ext cx="2717292" cy="348996"/>
+          </a:xfrm>
+          <a:prstGeom prst="rect">
+            <a:avLst/>
+          </a:prstGeom>
+        </p:spPr>
+      </p:pic>
+      <p:sp>
+        <p:nvSpPr>
+          <p:cNvPr id="12" name="TextBox 11"/>
+          <p:cNvSpPr txBox="1"/>
+          <p:nvPr/>
+        </p:nvSpPr>
+        <p:spPr>
+          <a:xfrm>
+            <a:off x="6217920" y="2723261"/>
+            <a:ext cx="5090160" cy="457200"/>
+          </a:xfrm>
+          <a:prstGeom prst="rect">
+            <a:avLst/>
+          </a:prstGeom>
+          <a:noFill/>
+        </p:spPr>
+        <p:txBody>
+          <a:bodyPr wrap="square" tIns="0" bIns="0">
+            <a:spAutoFit/>
+          </a:bodyPr>
+          <a:lstStyle/>
+          <a:p>
             <a:r>
               <a:rPr b="0" sz="1500">
                 <a:solidFill>
                   <a:srgbClr val="2B3648"/>
                 </a:solidFill>
               </a:rPr>
-              <a:t>Se = Snet,min (0.5 + Q/2)</a:t>
-            </a:r>
-          </a:p>
-          <a:p>
-            <a:pPr>
-              <a:spcAft>
-                <a:spcPts val="400"/>
-              </a:spcAft>
-            </a:pPr>
+              <a:t>•  Round corners for A and I; sharp corners permitted for J, C</a:t>
+            </a:r>
+            <a:r>
+              <a:rPr baseline="-25000" b="0" sz="1500">
+                <a:solidFill>
+                  <a:srgbClr val="2B3648"/>
+                </a:solidFill>
+              </a:rPr>
+              <a:t>w</a:t>
+            </a:r>
             <a:r>
               <a:rPr b="0" sz="1500">
                 <a:solidFill>
                   <a:srgbClr val="2B3648"/>
                 </a:solidFill>
               </a:rPr>
-              <a:t>Round corners for A and I; sharp corners permitted for J, Cw, ro</a:t>
-            </a:r>
-          </a:p>
-        </p:txBody>
-      </p:sp>
-      <p:sp>
-        <p:nvSpPr>
-          <p:cNvPr id="5" name="Rectangle 4"/>
+              <a:t>, r</a:t>
+            </a:r>
+            <a:r>
+              <a:rPr baseline="-25000" b="0" sz="1500">
+                <a:solidFill>
+                  <a:srgbClr val="2B3648"/>
+                </a:solidFill>
+              </a:rPr>
+              <a:t>o</a:t>
+            </a:r>
+          </a:p>
+        </p:txBody>
+      </p:sp>
+      <p:sp>
+        <p:nvSpPr>
+          <p:cNvPr id="13" name="Rectangle 12"/>
           <p:cNvSpPr/>
           <p:nvPr/>
         </p:nvSpPr>
         <p:spPr>
           <a:xfrm>
-            <a:off x="6172200" y="3380105"/>
-            <a:ext cx="5181600" cy="1463040"/>
+            <a:off x="6172200" y="3482213"/>
+            <a:ext cx="5181600" cy="1335024"/>
           </a:xfrm>
           <a:prstGeom prst="rect">
             <a:avLst/>
@@ -4917,14 +5264,35 @@
           </a:fontRef>
         </p:style>
         <p:txBody>
-          <a:bodyPr rtlCol="0" anchor="t" wrap="square" lIns="137160" rIns="137160" tIns="73152"/>
-          <a:lstStyle/>
-          <a:p>
-            <a:pPr algn="ctr">
-              <a:spcAft>
-                <a:spcPts val="600"/>
-              </a:spcAft>
-            </a:pPr>
+          <a:bodyPr rtlCol="0" anchor="ctr"/>
+          <a:lstStyle/>
+          <a:p>
+            <a:pPr algn="ctr"/>
+          </a:p>
+        </p:txBody>
+      </p:sp>
+      <p:sp>
+        <p:nvSpPr>
+          <p:cNvPr id="14" name="TextBox 13"/>
+          <p:cNvSpPr txBox="1"/>
+          <p:nvPr/>
+        </p:nvSpPr>
+        <p:spPr>
+          <a:xfrm>
+            <a:off x="6217920" y="3537077"/>
+            <a:ext cx="5181600" cy="320040"/>
+          </a:xfrm>
+          <a:prstGeom prst="rect">
+            <a:avLst/>
+          </a:prstGeom>
+          <a:noFill/>
+        </p:spPr>
+        <p:txBody>
+          <a:bodyPr wrap="none">
+            <a:spAutoFit/>
+          </a:bodyPr>
+          <a:lstStyle/>
+          <a:p>
             <a:r>
               <a:rPr b="1" sz="1400">
                 <a:solidFill>
@@ -4934,6 +5302,95 @@
               <a:t>Distortional (§4.1.3.2)</a:t>
             </a:r>
           </a:p>
+        </p:txBody>
+      </p:sp>
+      <p:sp>
+        <p:nvSpPr>
+          <p:cNvPr id="15" name="TextBox 14"/>
+          <p:cNvSpPr txBox="1"/>
+          <p:nvPr/>
+        </p:nvSpPr>
+        <p:spPr>
+          <a:xfrm>
+            <a:off x="6217920" y="3939413"/>
+            <a:ext cx="5090160" cy="457200"/>
+          </a:xfrm>
+          <a:prstGeom prst="rect">
+            <a:avLst/>
+          </a:prstGeom>
+          <a:noFill/>
+        </p:spPr>
+        <p:txBody>
+          <a:bodyPr wrap="square" tIns="0" bIns="0">
+            <a:spAutoFit/>
+          </a:bodyPr>
+          <a:lstStyle/>
+          <a:p>
+            <a:r>
+              <a:rPr b="0" sz="1500">
+                <a:solidFill>
+                  <a:srgbClr val="2B3648"/>
+                </a:solidFill>
+              </a:rPr>
+              <a:t>•  One sentence: certain open sections "shall be checked … by testing or rational analysis"</a:t>
+            </a:r>
+          </a:p>
+        </p:txBody>
+      </p:sp>
+      <p:sp>
+        <p:nvSpPr>
+          <p:cNvPr id="16" name="TextBox 15"/>
+          <p:cNvSpPr txBox="1"/>
+          <p:nvPr/>
+        </p:nvSpPr>
+        <p:spPr>
+          <a:xfrm>
+            <a:off x="6217920" y="4469765"/>
+            <a:ext cx="5090160" cy="228600"/>
+          </a:xfrm>
+          <a:prstGeom prst="rect">
+            <a:avLst/>
+          </a:prstGeom>
+          <a:noFill/>
+        </p:spPr>
+        <p:txBody>
+          <a:bodyPr wrap="square" tIns="0" bIns="0">
+            <a:spAutoFit/>
+          </a:bodyPr>
+          <a:lstStyle/>
+          <a:p>
+            <a:r>
+              <a:rPr b="0" sz="1500">
+                <a:solidFill>
+                  <a:srgbClr val="2B3648"/>
+                </a:solidFill>
+              </a:rPr>
+              <a:t>•  No equations, no elastic buckling load</a:t>
+            </a:r>
+          </a:p>
+        </p:txBody>
+      </p:sp>
+      <p:sp>
+        <p:nvSpPr>
+          <p:cNvPr id="17" name="TextBox 16"/>
+          <p:cNvSpPr txBox="1"/>
+          <p:nvPr/>
+        </p:nvSpPr>
+        <p:spPr>
+          <a:xfrm>
+            <a:off x="838200" y="5577840"/>
+            <a:ext cx="10515600" cy="457200"/>
+          </a:xfrm>
+          <a:prstGeom prst="rect">
+            <a:avLst/>
+          </a:prstGeom>
+          <a:noFill/>
+        </p:spPr>
+        <p:txBody>
+          <a:bodyPr wrap="square">
+            <a:spAutoFit/>
+          </a:bodyPr>
+          <a:lstStyle/>
           <a:p>
             <a:pPr>
               <a:spcAft>
@@ -4941,65 +5398,44 @@
               </a:spcAft>
             </a:pPr>
             <a:r>
-              <a:rPr b="0" sz="1500">
-                <a:solidFill>
-                  <a:srgbClr val="2B3648"/>
-                </a:solidFill>
-              </a:rPr>
-              <a:t>One sentence: certain open sections "shall be checked … by testing or rational analysis"</a:t>
-            </a:r>
-          </a:p>
-          <a:p>
-            <a:pPr>
-              <a:spcAft>
-                <a:spcPts val="400"/>
-              </a:spcAft>
-            </a:pPr>
-            <a:r>
-              <a:rPr b="0" sz="1500">
-                <a:solidFill>
-                  <a:srgbClr val="2B3648"/>
-                </a:solidFill>
-              </a:rPr>
-              <a:t>No equations, no elastic buckling load</a:t>
-            </a:r>
-          </a:p>
-        </p:txBody>
-      </p:sp>
-      <p:sp>
-        <p:nvSpPr>
-          <p:cNvPr id="6" name="TextBox 5"/>
-          <p:cNvSpPr txBox="1"/>
-          <p:nvPr/>
-        </p:nvSpPr>
-        <p:spPr>
-          <a:xfrm>
-            <a:off x="838200" y="5117465"/>
-            <a:ext cx="10515600" cy="457200"/>
-          </a:xfrm>
-          <a:prstGeom prst="rect">
-            <a:avLst/>
-          </a:prstGeom>
-          <a:noFill/>
-        </p:spPr>
-        <p:txBody>
-          <a:bodyPr wrap="square">
-            <a:spAutoFit/>
-          </a:bodyPr>
-          <a:lstStyle/>
-          <a:p>
-            <a:pPr>
-              <a:spcAft>
-                <a:spcPts val="400"/>
-              </a:spcAft>
-            </a:pPr>
-            <a:r>
               <a:rPr b="0" sz="1400">
                 <a:solidFill>
                   <a:srgbClr val="4B5666"/>
                 </a:solidFill>
               </a:rPr>
-              <a:t>Frame stability by the effective length method: down-aisle Kx = 1.7 for unbraced racks, Kt = 0.8</a:t>
+              <a:t>Frame stability by the effective length method: down-aisle K</a:t>
+            </a:r>
+            <a:r>
+              <a:rPr baseline="-25000" b="0" sz="1400">
+                <a:solidFill>
+                  <a:srgbClr val="4B5666"/>
+                </a:solidFill>
+              </a:rPr>
+              <a:t>x</a:t>
+            </a:r>
+            <a:r>
+              <a:rPr b="0" sz="1400">
+                <a:solidFill>
+                  <a:srgbClr val="4B5666"/>
+                </a:solidFill>
+              </a:rPr>
+              <a:t> = 1.7 for unbraced racks, K</a:t>
+            </a:r>
+            <a:r>
+              <a:rPr baseline="-25000" b="0" sz="1400">
+                <a:solidFill>
+                  <a:srgbClr val="4B5666"/>
+                </a:solidFill>
+              </a:rPr>
+              <a:t>t</a:t>
+            </a:r>
+            <a:r>
+              <a:rPr b="0" sz="1400">
+                <a:solidFill>
+                  <a:srgbClr val="4B5666"/>
+                </a:solidFill>
+              </a:rPr>
+              <a:t> = 0.8</a:t>
             </a:r>
           </a:p>
         </p:txBody>
@@ -5106,94 +5542,170 @@
       </p:sp>
       <p:sp>
         <p:nvSpPr>
-          <p:cNvPr id="3" name="Content Placeholder 2"/>
-          <p:cNvSpPr>
-            <a:spLocks noGrp="1"/>
-          </p:cNvSpPr>
-          <p:nvPr>
-            <p:ph idx="1" sz="half"/>
-          </p:nvPr>
-        </p:nvSpPr>
-        <p:spPr/>
-        <p:txBody>
-          <a:bodyPr wrap="square"/>
-          <a:lstStyle/>
-          <a:p>
-            <a:pPr>
-              <a:spcAft>
-                <a:spcPts val="400"/>
-              </a:spcAft>
-            </a:pPr>
-            <a:r>
-              <a:rPr b="0" sz="1600"/>
-              <a:t>Section properties use </a:t>
-            </a:r>
-            <a:r>
-              <a:rPr b="1" sz="1600"/>
+          <p:cNvPr id="3" name="TextBox 2"/>
+          <p:cNvSpPr txBox="1"/>
+          <p:nvPr/>
+        </p:nvSpPr>
+        <p:spPr>
+          <a:xfrm>
+            <a:off x="838200" y="1825625"/>
+            <a:ext cx="5181600" cy="731519"/>
+          </a:xfrm>
+          <a:prstGeom prst="rect">
+            <a:avLst/>
+          </a:prstGeom>
+          <a:noFill/>
+        </p:spPr>
+        <p:txBody>
+          <a:bodyPr wrap="square" tIns="0" bIns="0">
+            <a:spAutoFit/>
+          </a:bodyPr>
+          <a:lstStyle/>
+          <a:p>
+            <a:r>
+              <a:rPr b="0" sz="1600">
+                <a:solidFill>
+                  <a:srgbClr val="2B3648"/>
+                </a:solidFill>
+              </a:rPr>
+              <a:t>•  Section properties use </a:t>
+            </a:r>
+            <a:r>
+              <a:rPr b="1" sz="1600">
+                <a:solidFill>
+                  <a:srgbClr val="2B3648"/>
+                </a:solidFill>
+              </a:rPr>
               <a:t>round corners</a:t>
             </a:r>
             <a:r>
-              <a:rPr b="0" sz="1600"/>
-              <a:t> for everything, including J and Cw (sharp corners are unconservative for torsion)</a:t>
-            </a:r>
-          </a:p>
-          <a:p>
-            <a:pPr>
-              <a:spcAft>
-                <a:spcPts val="400"/>
-              </a:spcAft>
-            </a:pPr>
-            <a:r>
-              <a:rPr b="0" sz="1600"/>
-              <a:t>Each strip of web or flange that contains perforations is replaced by a solid strip of reduced thickness</a:t>
-            </a:r>
-          </a:p>
-          <a:p>
-            <a:pPr>
-              <a:spcAft>
-                <a:spcPts val="400"/>
-              </a:spcAft>
-            </a:pPr>
-            <a:r>
-              <a:rPr b="1" sz="1600"/>
+              <a:rPr b="0" sz="1600">
+                <a:solidFill>
+                  <a:srgbClr val="2B3648"/>
+                </a:solidFill>
+              </a:rPr>
+              <a:t> for everything, including J and C</a:t>
+            </a:r>
+            <a:r>
+              <a:rPr baseline="-25000" b="0" sz="1600">
+                <a:solidFill>
+                  <a:srgbClr val="2B3648"/>
+                </a:solidFill>
+              </a:rPr>
+              <a:t>w</a:t>
+            </a:r>
+            <a:r>
+              <a:rPr b="0" sz="1600">
+                <a:solidFill>
+                  <a:srgbClr val="2B3648"/>
+                </a:solidFill>
+              </a:rPr>
+              <a:t> (sharp corners are unconservative for torsion)</a:t>
+            </a:r>
+          </a:p>
+        </p:txBody>
+      </p:sp>
+      <p:sp>
+        <p:nvSpPr>
+          <p:cNvPr id="4" name="TextBox 3"/>
+          <p:cNvSpPr txBox="1"/>
+          <p:nvPr/>
+        </p:nvSpPr>
+        <p:spPr>
+          <a:xfrm>
+            <a:off x="838200" y="2630296"/>
+            <a:ext cx="5181600" cy="731519"/>
+          </a:xfrm>
+          <a:prstGeom prst="rect">
+            <a:avLst/>
+          </a:prstGeom>
+          <a:noFill/>
+        </p:spPr>
+        <p:txBody>
+          <a:bodyPr wrap="square" tIns="0" bIns="0">
+            <a:spAutoFit/>
+          </a:bodyPr>
+          <a:lstStyle/>
+          <a:p>
+            <a:r>
+              <a:rPr b="0" sz="1600">
+                <a:solidFill>
+                  <a:srgbClr val="2B3648"/>
+                </a:solidFill>
+              </a:rPr>
+              <a:t>•  Each strip of web or flange that contains perforations is replaced by a solid strip of reduced thickness</a:t>
+            </a:r>
+          </a:p>
+        </p:txBody>
+      </p:sp>
+      <p:sp>
+        <p:nvSpPr>
+          <p:cNvPr id="5" name="TextBox 4"/>
+          <p:cNvSpPr txBox="1"/>
+          <p:nvPr/>
+        </p:nvSpPr>
+        <p:spPr>
+          <a:xfrm>
+            <a:off x="838200" y="3434967"/>
+            <a:ext cx="5181600" cy="243840"/>
+          </a:xfrm>
+          <a:prstGeom prst="rect">
+            <a:avLst/>
+          </a:prstGeom>
+          <a:noFill/>
+        </p:spPr>
+        <p:txBody>
+          <a:bodyPr wrap="square" tIns="0" bIns="0">
+            <a:spAutoFit/>
+          </a:bodyPr>
+          <a:lstStyle/>
+          <a:p>
+            <a:r>
+              <a:rPr b="0" sz="1600">
+                <a:solidFill>
+                  <a:srgbClr val="2B3648"/>
+                </a:solidFill>
+              </a:rPr>
+              <a:t>•  </a:t>
+            </a:r>
+            <a:r>
+              <a:rPr b="1" sz="1600">
+                <a:solidFill>
+                  <a:srgbClr val="2B3648"/>
+                </a:solidFill>
+              </a:rPr>
               <a:t>Global and local</a:t>
             </a:r>
             <a:r>
-              <a:rPr b="0" sz="1600"/>
-              <a:t> buckling, kg = 0.6:   tg = kg t (Lnp / L)</a:t>
-            </a:r>
-          </a:p>
-          <a:p>
-            <a:pPr>
-              <a:spcAft>
-                <a:spcPts val="400"/>
-              </a:spcAft>
-            </a:pPr>
-            <a:r>
-              <a:rPr b="1" sz="1600"/>
-              <a:t>Distortional</a:t>
-            </a:r>
-            <a:r>
-              <a:rPr b="0" sz="1600"/>
-              <a:t> buckling, kd = 0.8:   td = kd t (Lnp / L)^(1/3)</a:t>
-            </a:r>
-          </a:p>
-          <a:p>
-            <a:pPr>
-              <a:spcAft>
-                <a:spcPts val="400"/>
-              </a:spcAft>
-            </a:pPr>
-            <a:r>
-              <a:rPr b="0" sz="1600"/>
-              <a:t>Lnp is the solid length between holes, L the pitch</a:t>
+              <a:rPr b="0" sz="1600">
+                <a:solidFill>
+                  <a:srgbClr val="2B3648"/>
+                </a:solidFill>
+              </a:rPr>
+              <a:t> buckling, k</a:t>
+            </a:r>
+            <a:r>
+              <a:rPr baseline="-25000" b="0" sz="1600">
+                <a:solidFill>
+                  <a:srgbClr val="2B3648"/>
+                </a:solidFill>
+              </a:rPr>
+              <a:t>g</a:t>
+            </a:r>
+            <a:r>
+              <a:rPr b="0" sz="1600">
+                <a:solidFill>
+                  <a:srgbClr val="2B3648"/>
+                </a:solidFill>
+              </a:rPr>
+              <a:t> = 0.6:</a:t>
             </a:r>
           </a:p>
         </p:txBody>
       </p:sp>
       <p:pic>
         <p:nvPicPr>
-          <p:cNvPr id="4" name="Picture 3" descr="fig_strips.png"/>
+          <p:cNvPr id="6" name="Picture 5" descr="tg.png"/>
           <p:cNvPicPr>
             <a:picLocks noChangeAspect="1"/>
           </p:cNvPicPr>
@@ -5207,8 +5719,8 @@
         </p:blipFill>
         <p:spPr>
           <a:xfrm>
-            <a:off x="6172200" y="1825625"/>
-            <a:ext cx="5181600" cy="2226803"/>
+            <a:off x="975360" y="3770247"/>
+            <a:ext cx="1808988" cy="707136"/>
           </a:xfrm>
           <a:prstGeom prst="rect">
             <a:avLst/>
@@ -5217,14 +5729,14 @@
       </p:pic>
       <p:sp>
         <p:nvSpPr>
-          <p:cNvPr id="5" name="TextBox 4"/>
+          <p:cNvPr id="7" name="TextBox 6"/>
           <p:cNvSpPr txBox="1"/>
           <p:nvPr/>
         </p:nvSpPr>
         <p:spPr>
           <a:xfrm>
-            <a:off x="6172200" y="4098148"/>
-            <a:ext cx="5181600" cy="457200"/>
+            <a:off x="838200" y="4550535"/>
+            <a:ext cx="5181600" cy="243840"/>
           </a:xfrm>
           <a:prstGeom prst="rect">
             <a:avLst/>
@@ -5232,6 +5744,168 @@
           <a:noFill/>
         </p:spPr>
         <p:txBody>
+          <a:bodyPr wrap="square" tIns="0" bIns="0">
+            <a:spAutoFit/>
+          </a:bodyPr>
+          <a:lstStyle/>
+          <a:p>
+            <a:r>
+              <a:rPr b="0" sz="1600">
+                <a:solidFill>
+                  <a:srgbClr val="2B3648"/>
+                </a:solidFill>
+              </a:rPr>
+              <a:t>•  </a:t>
+            </a:r>
+            <a:r>
+              <a:rPr b="1" sz="1600">
+                <a:solidFill>
+                  <a:srgbClr val="2B3648"/>
+                </a:solidFill>
+              </a:rPr>
+              <a:t>Distortional</a:t>
+            </a:r>
+            <a:r>
+              <a:rPr b="0" sz="1600">
+                <a:solidFill>
+                  <a:srgbClr val="2B3648"/>
+                </a:solidFill>
+              </a:rPr>
+              <a:t> buckling, k</a:t>
+            </a:r>
+            <a:r>
+              <a:rPr baseline="-25000" b="0" sz="1600">
+                <a:solidFill>
+                  <a:srgbClr val="2B3648"/>
+                </a:solidFill>
+              </a:rPr>
+              <a:t>d</a:t>
+            </a:r>
+            <a:r>
+              <a:rPr b="0" sz="1600">
+                <a:solidFill>
+                  <a:srgbClr val="2B3648"/>
+                </a:solidFill>
+              </a:rPr>
+              <a:t> = 0.8:</a:t>
+            </a:r>
+          </a:p>
+        </p:txBody>
+      </p:sp>
+      <p:pic>
+        <p:nvPicPr>
+          <p:cNvPr id="8" name="Picture 7" descr="td.png"/>
+          <p:cNvPicPr>
+            <a:picLocks noChangeAspect="1"/>
+          </p:cNvPicPr>
+          <p:nvPr/>
+        </p:nvPicPr>
+        <p:blipFill>
+          <a:blip r:embed="rId3"/>
+          <a:stretch>
+            <a:fillRect/>
+          </a:stretch>
+        </p:blipFill>
+        <p:spPr>
+          <a:xfrm>
+            <a:off x="975360" y="4885815"/>
+            <a:ext cx="2083308" cy="772668"/>
+          </a:xfrm>
+          <a:prstGeom prst="rect">
+            <a:avLst/>
+          </a:prstGeom>
+        </p:spPr>
+      </p:pic>
+      <p:sp>
+        <p:nvSpPr>
+          <p:cNvPr id="9" name="TextBox 8"/>
+          <p:cNvSpPr txBox="1"/>
+          <p:nvPr/>
+        </p:nvSpPr>
+        <p:spPr>
+          <a:xfrm>
+            <a:off x="838200" y="5731635"/>
+            <a:ext cx="5181600" cy="487680"/>
+          </a:xfrm>
+          <a:prstGeom prst="rect">
+            <a:avLst/>
+          </a:prstGeom>
+          <a:noFill/>
+        </p:spPr>
+        <p:txBody>
+          <a:bodyPr wrap="square" tIns="0" bIns="0">
+            <a:spAutoFit/>
+          </a:bodyPr>
+          <a:lstStyle/>
+          <a:p>
+            <a:r>
+              <a:rPr b="0" sz="1600">
+                <a:solidFill>
+                  <a:srgbClr val="2B3648"/>
+                </a:solidFill>
+              </a:rPr>
+              <a:t>•  L</a:t>
+            </a:r>
+            <a:r>
+              <a:rPr baseline="-25000" b="0" sz="1600">
+                <a:solidFill>
+                  <a:srgbClr val="2B3648"/>
+                </a:solidFill>
+              </a:rPr>
+              <a:t>np</a:t>
+            </a:r>
+            <a:r>
+              <a:rPr b="0" sz="1600">
+                <a:solidFill>
+                  <a:srgbClr val="2B3648"/>
+                </a:solidFill>
+              </a:rPr>
+              <a:t> is the solid length between holes, L the pitch</a:t>
+            </a:r>
+          </a:p>
+        </p:txBody>
+      </p:sp>
+      <p:pic>
+        <p:nvPicPr>
+          <p:cNvPr id="10" name="Picture 9" descr="fig_strips.png"/>
+          <p:cNvPicPr>
+            <a:picLocks noChangeAspect="1"/>
+          </p:cNvPicPr>
+          <p:nvPr/>
+        </p:nvPicPr>
+        <p:blipFill>
+          <a:blip r:embed="rId4"/>
+          <a:stretch>
+            <a:fillRect/>
+          </a:stretch>
+        </p:blipFill>
+        <p:spPr>
+          <a:xfrm>
+            <a:off x="6172200" y="1825625"/>
+            <a:ext cx="5181600" cy="2226803"/>
+          </a:xfrm>
+          <a:prstGeom prst="rect">
+            <a:avLst/>
+          </a:prstGeom>
+        </p:spPr>
+      </p:pic>
+      <p:sp>
+        <p:nvSpPr>
+          <p:cNvPr id="11" name="TextBox 10"/>
+          <p:cNvSpPr txBox="1"/>
+          <p:nvPr/>
+        </p:nvSpPr>
+        <p:spPr>
+          <a:xfrm>
+            <a:off x="6172200" y="4098148"/>
+            <a:ext cx="5181600" cy="457200"/>
+          </a:xfrm>
+          <a:prstGeom prst="rect">
+            <a:avLst/>
+          </a:prstGeom>
+          <a:noFill/>
+        </p:spPr>
+        <p:txBody>
           <a:bodyPr wrap="square">
             <a:spAutoFit/>
           </a:bodyPr>
@@ -5251,7 +5925,7 @@
       </p:sp>
       <p:sp>
         <p:nvSpPr>
-          <p:cNvPr id="6" name="TextBox 5"/>
+          <p:cNvPr id="12" name="TextBox 11"/>
           <p:cNvSpPr txBox="1"/>
           <p:nvPr/>
         </p:nvSpPr>
@@ -5278,7 +5952,19 @@
             </a:pPr>
             <a:r>
               <a:rPr b="0" sz="1500"/>
-              <a:t>•  One idealized section feeds the frame model (§7.2.4), the global buckling check, and the finite strip model for Pcrd and Mcrd</a:t>
+              <a:t>•  One idealized section feeds the frame model (§7.2.4), the global buckling check, and the finite strip model for P</a:t>
+            </a:r>
+            <a:r>
+              <a:rPr baseline="-25000" b="0" sz="1500"/>
+              <a:t>crd</a:t>
+            </a:r>
+            <a:r>
+              <a:rPr b="0" sz="1500"/>
+              <a:t> and M</a:t>
+            </a:r>
+            <a:r>
+              <a:rPr baseline="-25000" b="0" sz="1500"/>
+              <a:t>crd</a:t>
             </a:r>
           </a:p>
         </p:txBody>
@@ -5391,8 +6077,8 @@
         </p:nvSpPr>
         <p:spPr>
           <a:xfrm>
-            <a:off x="838200" y="1825625"/>
-            <a:ext cx="5181600" cy="1783080"/>
+            <a:off x="838200" y="1642745"/>
+            <a:ext cx="5181600" cy="1868856"/>
           </a:xfrm>
           <a:prstGeom prst="rect">
             <a:avLst/>
@@ -5422,14 +6108,35 @@
           </a:fontRef>
         </p:style>
         <p:txBody>
-          <a:bodyPr rtlCol="0" anchor="t" wrap="square" lIns="137160" rIns="137160" tIns="73152"/>
-          <a:lstStyle/>
-          <a:p>
-            <a:pPr algn="ctr">
-              <a:spcAft>
-                <a:spcPts val="600"/>
-              </a:spcAft>
-            </a:pPr>
+          <a:bodyPr rtlCol="0" anchor="ctr"/>
+          <a:lstStyle/>
+          <a:p>
+            <a:pPr algn="ctr"/>
+          </a:p>
+        </p:txBody>
+      </p:sp>
+      <p:sp>
+        <p:nvSpPr>
+          <p:cNvPr id="4" name="TextBox 3"/>
+          <p:cNvSpPr txBox="1"/>
+          <p:nvPr/>
+        </p:nvSpPr>
+        <p:spPr>
+          <a:xfrm>
+            <a:off x="883920" y="1697609"/>
+            <a:ext cx="5181600" cy="320040"/>
+          </a:xfrm>
+          <a:prstGeom prst="rect">
+            <a:avLst/>
+          </a:prstGeom>
+          <a:noFill/>
+        </p:spPr>
+        <p:txBody>
+          <a:bodyPr wrap="none">
+            <a:spAutoFit/>
+          </a:bodyPr>
+          <a:lstStyle/>
+          <a:p>
             <a:r>
               <a:rPr b="1" sz="1400">
                 <a:solidFill>
@@ -5439,48 +6146,139 @@
               <a:t>Global (8.2-3, 8.2-4)</a:t>
             </a:r>
           </a:p>
-          <a:p>
-            <a:pPr>
-              <a:spcAft>
-                <a:spcPts val="400"/>
-              </a:spcAft>
-            </a:pPr>
+        </p:txBody>
+      </p:sp>
+      <p:pic>
+        <p:nvPicPr>
+          <p:cNvPr id="5" name="Picture 4" descr="pne.png"/>
+          <p:cNvPicPr>
+            <a:picLocks noChangeAspect="1"/>
+          </p:cNvPicPr>
+          <p:nvPr/>
+        </p:nvPicPr>
+        <p:blipFill>
+          <a:blip r:embed="rId2"/>
+          <a:stretch>
+            <a:fillRect/>
+          </a:stretch>
+        </p:blipFill>
+        <p:spPr>
+          <a:xfrm>
+            <a:off x="1021080" y="2118233"/>
+            <a:ext cx="4815840" cy="972744"/>
+          </a:xfrm>
+          <a:prstGeom prst="rect">
+            <a:avLst/>
+          </a:prstGeom>
+        </p:spPr>
+      </p:pic>
+      <p:sp>
+        <p:nvSpPr>
+          <p:cNvPr id="6" name="TextBox 5"/>
+          <p:cNvSpPr txBox="1"/>
+          <p:nvPr/>
+        </p:nvSpPr>
+        <p:spPr>
+          <a:xfrm>
+            <a:off x="883920" y="3164129"/>
+            <a:ext cx="5090160" cy="228600"/>
+          </a:xfrm>
+          <a:prstGeom prst="rect">
+            <a:avLst/>
+          </a:prstGeom>
+          <a:noFill/>
+        </p:spPr>
+        <p:txBody>
+          <a:bodyPr wrap="square" tIns="0" bIns="0">
+            <a:spAutoFit/>
+          </a:bodyPr>
+          <a:lstStyle/>
+          <a:p>
             <a:r>
               <a:rPr b="0" sz="1500">
                 <a:solidFill>
                   <a:srgbClr val="2B3648"/>
                 </a:solidFill>
               </a:rPr>
-              <a:t>Pne = 0.658^(λc²) Py  for λc ≤ 1.5;   Pne = (0.877 / λc²) Py  for λc &gt; 1.5</a:t>
-            </a:r>
-          </a:p>
-          <a:p>
-            <a:pPr>
-              <a:spcAft>
-                <a:spcPts val="400"/>
-              </a:spcAft>
-            </a:pPr>
+              <a:t>P</a:t>
+            </a:r>
+            <a:r>
+              <a:rPr baseline="-25000" b="0" sz="1500">
+                <a:solidFill>
+                  <a:srgbClr val="2B3648"/>
+                </a:solidFill>
+              </a:rPr>
+              <a:t>y</a:t>
+            </a:r>
             <a:r>
               <a:rPr b="0" sz="1500">
                 <a:solidFill>
                   <a:srgbClr val="2B3648"/>
                 </a:solidFill>
               </a:rPr>
-              <a:t>λc = √(Py / Pcre),  Py = Fy Anetg;  Pcre with K, L from §10.2, §10.3</a:t>
-            </a:r>
-          </a:p>
-        </p:txBody>
-      </p:sp>
-      <p:sp>
-        <p:nvSpPr>
-          <p:cNvPr id="4" name="Rectangle 3"/>
+              <a:t> = F</a:t>
+            </a:r>
+            <a:r>
+              <a:rPr baseline="-25000" b="0" sz="1500">
+                <a:solidFill>
+                  <a:srgbClr val="2B3648"/>
+                </a:solidFill>
+              </a:rPr>
+              <a:t>y</a:t>
+            </a:r>
+            <a:r>
+              <a:rPr b="0" sz="1500">
+                <a:solidFill>
+                  <a:srgbClr val="2B3648"/>
+                </a:solidFill>
+              </a:rPr>
+              <a:t> A</a:t>
+            </a:r>
+            <a:r>
+              <a:rPr baseline="-25000" b="0" sz="1500">
+                <a:solidFill>
+                  <a:srgbClr val="2B3648"/>
+                </a:solidFill>
+              </a:rPr>
+              <a:t>netg</a:t>
+            </a:r>
+            <a:r>
+              <a:rPr b="0" sz="1500">
+                <a:solidFill>
+                  <a:srgbClr val="2B3648"/>
+                </a:solidFill>
+              </a:rPr>
+              <a:t>; P</a:t>
+            </a:r>
+            <a:r>
+              <a:rPr baseline="-25000" b="0" sz="1500">
+                <a:solidFill>
+                  <a:srgbClr val="2B3648"/>
+                </a:solidFill>
+              </a:rPr>
+              <a:t>cre</a:t>
+            </a:r>
+            <a:r>
+              <a:rPr b="0" sz="1500">
+                <a:solidFill>
+                  <a:srgbClr val="2B3648"/>
+                </a:solidFill>
+              </a:rPr>
+              <a:t> with K, L from §10.2, §10.3</a:t>
+            </a:r>
+          </a:p>
+        </p:txBody>
+      </p:sp>
+      <p:sp>
+        <p:nvSpPr>
+          <p:cNvPr id="7" name="Rectangle 6"/>
           <p:cNvSpPr/>
           <p:nvPr/>
         </p:nvSpPr>
         <p:spPr>
           <a:xfrm>
-            <a:off x="838200" y="3791585"/>
-            <a:ext cx="5181600" cy="1783080"/>
+            <a:off x="838200" y="3694481"/>
+            <a:ext cx="5181600" cy="1972756"/>
           </a:xfrm>
           <a:prstGeom prst="rect">
             <a:avLst/>
@@ -5510,14 +6308,35 @@
           </a:fontRef>
         </p:style>
         <p:txBody>
-          <a:bodyPr rtlCol="0" anchor="t" wrap="square" lIns="137160" rIns="137160" tIns="73152"/>
-          <a:lstStyle/>
-          <a:p>
-            <a:pPr algn="ctr">
-              <a:spcAft>
-                <a:spcPts val="600"/>
-              </a:spcAft>
-            </a:pPr>
+          <a:bodyPr rtlCol="0" anchor="ctr"/>
+          <a:lstStyle/>
+          <a:p>
+            <a:pPr algn="ctr"/>
+          </a:p>
+        </p:txBody>
+      </p:sp>
+      <p:sp>
+        <p:nvSpPr>
+          <p:cNvPr id="8" name="TextBox 7"/>
+          <p:cNvSpPr txBox="1"/>
+          <p:nvPr/>
+        </p:nvSpPr>
+        <p:spPr>
+          <a:xfrm>
+            <a:off x="883920" y="3749345"/>
+            <a:ext cx="5181600" cy="320040"/>
+          </a:xfrm>
+          <a:prstGeom prst="rect">
+            <a:avLst/>
+          </a:prstGeom>
+          <a:noFill/>
+        </p:spPr>
+        <p:txBody>
+          <a:bodyPr wrap="none">
+            <a:spAutoFit/>
+          </a:bodyPr>
+          <a:lstStyle/>
+          <a:p>
             <a:r>
               <a:rPr b="1" sz="1400">
                 <a:solidFill>
@@ -5527,48 +6346,107 @@
               <a:t>Local + global (8.2-5, 8.2-6)</a:t>
             </a:r>
           </a:p>
-          <a:p>
-            <a:pPr>
-              <a:spcAft>
-                <a:spcPts val="400"/>
-              </a:spcAft>
-            </a:pPr>
+        </p:txBody>
+      </p:sp>
+      <p:pic>
+        <p:nvPicPr>
+          <p:cNvPr id="9" name="Picture 8" descr="pnlg.png"/>
+          <p:cNvPicPr>
+            <a:picLocks noChangeAspect="1"/>
+          </p:cNvPicPr>
+          <p:nvPr/>
+        </p:nvPicPr>
+        <p:blipFill>
+          <a:blip r:embed="rId3"/>
+          <a:stretch>
+            <a:fillRect/>
+          </a:stretch>
+        </p:blipFill>
+        <p:spPr>
+          <a:xfrm>
+            <a:off x="1021080" y="4169969"/>
+            <a:ext cx="4815840" cy="848044"/>
+          </a:xfrm>
+          <a:prstGeom prst="rect">
+            <a:avLst/>
+          </a:prstGeom>
+        </p:spPr>
+      </p:pic>
+      <p:sp>
+        <p:nvSpPr>
+          <p:cNvPr id="10" name="TextBox 9"/>
+          <p:cNvSpPr txBox="1"/>
+          <p:nvPr/>
+        </p:nvSpPr>
+        <p:spPr>
+          <a:xfrm>
+            <a:off x="883920" y="5091165"/>
+            <a:ext cx="5090160" cy="457200"/>
+          </a:xfrm>
+          <a:prstGeom prst="rect">
+            <a:avLst/>
+          </a:prstGeom>
+          <a:noFill/>
+        </p:spPr>
+        <p:txBody>
+          <a:bodyPr wrap="square" tIns="0" bIns="0">
+            <a:spAutoFit/>
+          </a:bodyPr>
+          <a:lstStyle/>
+          <a:p>
             <a:r>
               <a:rPr b="0" sz="1500">
                 <a:solidFill>
                   <a:srgbClr val="2B3648"/>
                 </a:solidFill>
               </a:rPr>
-              <a:t>Pnlg = Pne [1 − (1 − Q)(Pne / Py)^(Q/(1−Q))],  Q &lt; 1</a:t>
-            </a:r>
-          </a:p>
-          <a:p>
-            <a:pPr>
-              <a:spcAft>
-                <a:spcPts val="400"/>
-              </a:spcAft>
-            </a:pPr>
+              <a:t>P</a:t>
+            </a:r>
+            <a:r>
+              <a:rPr baseline="-25000" b="0" sz="1500">
+                <a:solidFill>
+                  <a:srgbClr val="2B3648"/>
+                </a:solidFill>
+              </a:rPr>
+              <a:t>nlg</a:t>
+            </a:r>
             <a:r>
               <a:rPr b="0" sz="1500">
                 <a:solidFill>
                   <a:srgbClr val="2B3648"/>
                 </a:solidFill>
               </a:rPr>
-              <a:t>Pnlg = Pne if Q ≥ 1 (split out as its own equation in 2023)</a:t>
-            </a:r>
-          </a:p>
-        </p:txBody>
-      </p:sp>
-      <p:sp>
-        <p:nvSpPr>
-          <p:cNvPr id="5" name="Rectangle 4"/>
+              <a:t> = P</a:t>
+            </a:r>
+            <a:r>
+              <a:rPr baseline="-25000" b="0" sz="1500">
+                <a:solidFill>
+                  <a:srgbClr val="2B3648"/>
+                </a:solidFill>
+              </a:rPr>
+              <a:t>ne</a:t>
+            </a:r>
+            <a:r>
+              <a:rPr b="0" sz="1500">
+                <a:solidFill>
+                  <a:srgbClr val="2B3648"/>
+                </a:solidFill>
+              </a:rPr>
+              <a:t> if Q ≥ 1 (split out as its own equation in 2023)</a:t>
+            </a:r>
+          </a:p>
+        </p:txBody>
+      </p:sp>
+      <p:sp>
+        <p:nvSpPr>
+          <p:cNvPr id="11" name="Rectangle 10"/>
           <p:cNvSpPr/>
           <p:nvPr/>
         </p:nvSpPr>
         <p:spPr>
           <a:xfrm>
-            <a:off x="6172200" y="1825625"/>
-            <a:ext cx="5181600" cy="1783080"/>
+            <a:off x="6172200" y="1642745"/>
+            <a:ext cx="5181600" cy="1760220"/>
           </a:xfrm>
           <a:prstGeom prst="rect">
             <a:avLst/>
@@ -5598,65 +6476,23 @@
           </a:fontRef>
         </p:style>
         <p:txBody>
-          <a:bodyPr rtlCol="0" anchor="t" wrap="square" lIns="137160" rIns="137160" tIns="73152"/>
-          <a:lstStyle/>
-          <a:p>
-            <a:pPr algn="ctr">
-              <a:spcAft>
-                <a:spcPts val="600"/>
-              </a:spcAft>
-            </a:pPr>
-            <a:r>
-              <a:rPr b="1" sz="1400">
-                <a:solidFill>
-                  <a:srgbClr val="0E2841"/>
-                </a:solidFill>
-              </a:rPr>
-              <a:t>Distortional + global (8.2-7, 8.2-8)</a:t>
-            </a:r>
-          </a:p>
-          <a:p>
-            <a:pPr>
-              <a:spcAft>
-                <a:spcPts val="400"/>
-              </a:spcAft>
-            </a:pPr>
-            <a:r>
-              <a:rPr b="0" sz="1500">
-                <a:solidFill>
-                  <a:srgbClr val="2B3648"/>
-                </a:solidFill>
-              </a:rPr>
-              <a:t>Pnld = [1 − 0.25 (Pcrd / Pne)^0.6] (Pcrd / Pne)^0.6 · Pne</a:t>
-            </a:r>
-          </a:p>
-          <a:p>
-            <a:pPr>
-              <a:spcAft>
-                <a:spcPts val="400"/>
-              </a:spcAft>
-            </a:pPr>
-            <a:r>
-              <a:rPr b="0" sz="1500">
-                <a:solidFill>
-                  <a:srgbClr val="2B3648"/>
-                </a:solidFill>
-              </a:rPr>
-              <a:t>for λd = √(Pne / Pcrd) &gt; 0.561, else Pnld = Pne</a:t>
-            </a:r>
-          </a:p>
-        </p:txBody>
-      </p:sp>
-      <p:sp>
-        <p:nvSpPr>
-          <p:cNvPr id="6" name="TextBox 5"/>
+          <a:bodyPr rtlCol="0" anchor="ctr"/>
+          <a:lstStyle/>
+          <a:p>
+            <a:pPr algn="ctr"/>
+          </a:p>
+        </p:txBody>
+      </p:sp>
+      <p:sp>
+        <p:nvSpPr>
+          <p:cNvPr id="12" name="TextBox 11"/>
           <p:cNvSpPr txBox="1"/>
           <p:nvPr/>
         </p:nvSpPr>
         <p:spPr>
           <a:xfrm>
-            <a:off x="6172200" y="3791585"/>
-            <a:ext cx="5181600" cy="1828800"/>
+            <a:off x="6217920" y="1697609"/>
+            <a:ext cx="5181600" cy="320040"/>
           </a:xfrm>
           <a:prstGeom prst="rect">
             <a:avLst/>
@@ -5664,45 +6500,350 @@
           <a:noFill/>
         </p:spPr>
         <p:txBody>
-          <a:bodyPr wrap="square">
+          <a:bodyPr wrap="none">
             <a:spAutoFit/>
           </a:bodyPr>
           <a:lstStyle/>
           <a:p>
-            <a:pPr>
-              <a:spcAft>
-                <a:spcPts val="400"/>
-              </a:spcAft>
-            </a:pPr>
-            <a:r>
-              <a:rPr b="0" sz="1500"/>
+            <a:r>
+              <a:rPr b="1" sz="1400">
+                <a:solidFill>
+                  <a:srgbClr val="0E2841"/>
+                </a:solidFill>
+              </a:rPr>
+              <a:t>Distortional + global (8.2-7, 8.2-8)</a:t>
+            </a:r>
+          </a:p>
+        </p:txBody>
+      </p:sp>
+      <p:pic>
+        <p:nvPicPr>
+          <p:cNvPr id="13" name="Picture 12" descr="pnld.png"/>
+          <p:cNvPicPr>
+            <a:picLocks noChangeAspect="1"/>
+          </p:cNvPicPr>
+          <p:nvPr/>
+        </p:nvPicPr>
+        <p:blipFill>
+          <a:blip r:embed="rId4"/>
+          <a:stretch>
+            <a:fillRect/>
+          </a:stretch>
+        </p:blipFill>
+        <p:spPr>
+          <a:xfrm>
+            <a:off x="6355080" y="2118233"/>
+            <a:ext cx="4666488" cy="864108"/>
+          </a:xfrm>
+          <a:prstGeom prst="rect">
+            <a:avLst/>
+          </a:prstGeom>
+        </p:spPr>
+      </p:pic>
+      <p:sp>
+        <p:nvSpPr>
+          <p:cNvPr id="14" name="TextBox 13"/>
+          <p:cNvSpPr txBox="1"/>
+          <p:nvPr/>
+        </p:nvSpPr>
+        <p:spPr>
+          <a:xfrm>
+            <a:off x="6217920" y="3055493"/>
+            <a:ext cx="5090160" cy="228600"/>
+          </a:xfrm>
+          <a:prstGeom prst="rect">
+            <a:avLst/>
+          </a:prstGeom>
+          <a:noFill/>
+        </p:spPr>
+        <p:txBody>
+          <a:bodyPr wrap="square" tIns="0" bIns="0">
+            <a:spAutoFit/>
+          </a:bodyPr>
+          <a:lstStyle/>
+          <a:p>
+            <a:r>
+              <a:rPr b="0" sz="1500">
+                <a:solidFill>
+                  <a:srgbClr val="2B3648"/>
+                </a:solidFill>
+              </a:rPr>
+              <a:t>for λ</a:t>
+            </a:r>
+            <a:r>
+              <a:rPr baseline="-25000" b="0" sz="1500">
+                <a:solidFill>
+                  <a:srgbClr val="2B3648"/>
+                </a:solidFill>
+              </a:rPr>
+              <a:t>d</a:t>
+            </a:r>
+            <a:r>
+              <a:rPr b="0" sz="1500">
+                <a:solidFill>
+                  <a:srgbClr val="2B3648"/>
+                </a:solidFill>
+              </a:rPr>
+              <a:t> = √(P</a:t>
+            </a:r>
+            <a:r>
+              <a:rPr baseline="-25000" b="0" sz="1500">
+                <a:solidFill>
+                  <a:srgbClr val="2B3648"/>
+                </a:solidFill>
+              </a:rPr>
+              <a:t>ne</a:t>
+            </a:r>
+            <a:r>
+              <a:rPr b="0" sz="1500">
+                <a:solidFill>
+                  <a:srgbClr val="2B3648"/>
+                </a:solidFill>
+              </a:rPr>
+              <a:t> / P</a:t>
+            </a:r>
+            <a:r>
+              <a:rPr baseline="-25000" b="0" sz="1500">
+                <a:solidFill>
+                  <a:srgbClr val="2B3648"/>
+                </a:solidFill>
+              </a:rPr>
+              <a:t>crd</a:t>
+            </a:r>
+            <a:r>
+              <a:rPr b="0" sz="1500">
+                <a:solidFill>
+                  <a:srgbClr val="2B3648"/>
+                </a:solidFill>
+              </a:rPr>
+              <a:t>) &gt; 0.561, else P</a:t>
+            </a:r>
+            <a:r>
+              <a:rPr baseline="-25000" b="0" sz="1500">
+                <a:solidFill>
+                  <a:srgbClr val="2B3648"/>
+                </a:solidFill>
+              </a:rPr>
+              <a:t>nld</a:t>
+            </a:r>
+            <a:r>
+              <a:rPr b="0" sz="1500">
+                <a:solidFill>
+                  <a:srgbClr val="2B3648"/>
+                </a:solidFill>
+              </a:rPr>
+              <a:t> = P</a:t>
+            </a:r>
+            <a:r>
+              <a:rPr baseline="-25000" b="0" sz="1500">
+                <a:solidFill>
+                  <a:srgbClr val="2B3648"/>
+                </a:solidFill>
+              </a:rPr>
+              <a:t>ne</a:t>
+            </a:r>
+          </a:p>
+        </p:txBody>
+      </p:sp>
+      <p:sp>
+        <p:nvSpPr>
+          <p:cNvPr id="15" name="TextBox 14"/>
+          <p:cNvSpPr txBox="1"/>
+          <p:nvPr/>
+        </p:nvSpPr>
+        <p:spPr>
+          <a:xfrm>
+            <a:off x="6172200" y="3631565"/>
+            <a:ext cx="5181600" cy="243840"/>
+          </a:xfrm>
+          <a:prstGeom prst="rect">
+            <a:avLst/>
+          </a:prstGeom>
+          <a:noFill/>
+        </p:spPr>
+        <p:txBody>
+          <a:bodyPr wrap="square" tIns="0" bIns="0">
+            <a:spAutoFit/>
+          </a:bodyPr>
+          <a:lstStyle/>
+          <a:p>
+            <a:r>
+              <a:rPr b="0" sz="1600">
+                <a:solidFill>
+                  <a:srgbClr val="0E2841"/>
+                </a:solidFill>
+              </a:rPr>
               <a:t>•  </a:t>
             </a:r>
             <a:r>
-              <a:rPr b="1" sz="1500"/>
-              <a:t>Pn = min(Pnlg, Pnld)</a:t>
-            </a:r>
-          </a:p>
-          <a:p>
-            <a:pPr>
-              <a:spcAft>
-                <a:spcPts val="400"/>
-              </a:spcAft>
-            </a:pPr>
-            <a:r>
-              <a:rPr b="0" sz="1500"/>
-              <a:t>•  Pcrd: elastic distortional buckling "in accordance with ANSI/AISI S100" on the td section</a:t>
-            </a:r>
-          </a:p>
-          <a:p>
-            <a:pPr>
-              <a:spcAft>
-                <a:spcPts val="400"/>
-              </a:spcAft>
-            </a:pPr>
-            <a:r>
-              <a:rPr b="0" sz="1500"/>
-              <a:t>•  Hot-rolled and closed sections: Pnlg only</a:t>
+              <a:rPr b="1" sz="1600">
+                <a:solidFill>
+                  <a:srgbClr val="0E2841"/>
+                </a:solidFill>
+              </a:rPr>
+              <a:t>P</a:t>
+            </a:r>
+            <a:r>
+              <a:rPr baseline="-25000" b="1" sz="1600">
+                <a:solidFill>
+                  <a:srgbClr val="0E2841"/>
+                </a:solidFill>
+              </a:rPr>
+              <a:t>n</a:t>
+            </a:r>
+            <a:r>
+              <a:rPr b="1" sz="1600">
+                <a:solidFill>
+                  <a:srgbClr val="0E2841"/>
+                </a:solidFill>
+              </a:rPr>
+              <a:t> = min(P</a:t>
+            </a:r>
+            <a:r>
+              <a:rPr baseline="-25000" b="1" sz="1600">
+                <a:solidFill>
+                  <a:srgbClr val="0E2841"/>
+                </a:solidFill>
+              </a:rPr>
+              <a:t>nlg</a:t>
+            </a:r>
+            <a:r>
+              <a:rPr b="1" sz="1600">
+                <a:solidFill>
+                  <a:srgbClr val="0E2841"/>
+                </a:solidFill>
+              </a:rPr>
+              <a:t>, P</a:t>
+            </a:r>
+            <a:r>
+              <a:rPr baseline="-25000" b="1" sz="1600">
+                <a:solidFill>
+                  <a:srgbClr val="0E2841"/>
+                </a:solidFill>
+              </a:rPr>
+              <a:t>nld</a:t>
+            </a:r>
+            <a:r>
+              <a:rPr b="1" sz="1600">
+                <a:solidFill>
+                  <a:srgbClr val="0E2841"/>
+                </a:solidFill>
+              </a:rPr>
+              <a:t>)</a:t>
+            </a:r>
+          </a:p>
+        </p:txBody>
+      </p:sp>
+      <p:sp>
+        <p:nvSpPr>
+          <p:cNvPr id="16" name="TextBox 15"/>
+          <p:cNvSpPr txBox="1"/>
+          <p:nvPr/>
+        </p:nvSpPr>
+        <p:spPr>
+          <a:xfrm>
+            <a:off x="6172200" y="3948557"/>
+            <a:ext cx="5181600" cy="731519"/>
+          </a:xfrm>
+          <a:prstGeom prst="rect">
+            <a:avLst/>
+          </a:prstGeom>
+          <a:noFill/>
+        </p:spPr>
+        <p:txBody>
+          <a:bodyPr wrap="square" tIns="0" bIns="0">
+            <a:spAutoFit/>
+          </a:bodyPr>
+          <a:lstStyle/>
+          <a:p>
+            <a:r>
+              <a:rPr b="0" sz="1600">
+                <a:solidFill>
+                  <a:srgbClr val="0E2841"/>
+                </a:solidFill>
+              </a:rPr>
+              <a:t>•  P</a:t>
+            </a:r>
+            <a:r>
+              <a:rPr baseline="-25000" b="0" sz="1600">
+                <a:solidFill>
+                  <a:srgbClr val="0E2841"/>
+                </a:solidFill>
+              </a:rPr>
+              <a:t>crd</a:t>
+            </a:r>
+            <a:r>
+              <a:rPr b="0" sz="1600">
+                <a:solidFill>
+                  <a:srgbClr val="0E2841"/>
+                </a:solidFill>
+              </a:rPr>
+              <a:t>: elastic distortional buckling "in accordance with ANSI/AISI S100" on the t</a:t>
+            </a:r>
+            <a:r>
+              <a:rPr baseline="-25000" b="0" sz="1600">
+                <a:solidFill>
+                  <a:srgbClr val="0E2841"/>
+                </a:solidFill>
+              </a:rPr>
+              <a:t>d</a:t>
+            </a:r>
+            <a:r>
+              <a:rPr b="0" sz="1600">
+                <a:solidFill>
+                  <a:srgbClr val="0E2841"/>
+                </a:solidFill>
+              </a:rPr>
+              <a:t> section</a:t>
+            </a:r>
+          </a:p>
+        </p:txBody>
+      </p:sp>
+      <p:sp>
+        <p:nvSpPr>
+          <p:cNvPr id="17" name="TextBox 16"/>
+          <p:cNvSpPr txBox="1"/>
+          <p:nvPr/>
+        </p:nvSpPr>
+        <p:spPr>
+          <a:xfrm>
+            <a:off x="6172200" y="4753228"/>
+            <a:ext cx="5181600" cy="243840"/>
+          </a:xfrm>
+          <a:prstGeom prst="rect">
+            <a:avLst/>
+          </a:prstGeom>
+          <a:noFill/>
+        </p:spPr>
+        <p:txBody>
+          <a:bodyPr wrap="square" tIns="0" bIns="0">
+            <a:spAutoFit/>
+          </a:bodyPr>
+          <a:lstStyle/>
+          <a:p>
+            <a:r>
+              <a:rPr b="0" sz="1600">
+                <a:solidFill>
+                  <a:srgbClr val="0E2841"/>
+                </a:solidFill>
+              </a:rPr>
+              <a:t>•  Hot-rolled and closed sections: P</a:t>
+            </a:r>
+            <a:r>
+              <a:rPr baseline="-25000" b="0" sz="1600">
+                <a:solidFill>
+                  <a:srgbClr val="0E2841"/>
+                </a:solidFill>
+              </a:rPr>
+              <a:t>nlg</a:t>
+            </a:r>
+            <a:r>
+              <a:rPr b="0" sz="1600">
+                <a:solidFill>
+                  <a:srgbClr val="0E2841"/>
+                </a:solidFill>
+              </a:rPr>
+              <a:t> only</a:t>
             </a:r>
           </a:p>
         </p:txBody>
@@ -5837,7 +6978,15 @@
             </a:r>
             <a:r>
               <a:rPr b="0" sz="1600"/>
-              <a:t> a DSM check: there is no Pcrℓ. The perforation and local slenderness effects both come from the </a:t>
+              <a:t> a DSM check: there is no P</a:t>
+            </a:r>
+            <a:r>
+              <a:rPr baseline="-25000" b="0" sz="1600"/>
+              <a:t>crℓ</a:t>
+            </a:r>
+            <a:r>
+              <a:rPr b="0" sz="1600"/>
+              <a:t>. The perforation and local slenderness effects both come from the </a:t>
             </a:r>
             <a:r>
               <a:rPr b="1" sz="1600"/>
@@ -5845,7 +6994,47 @@
             </a:r>
             <a:r>
               <a:rPr b="0" sz="1600"/>
-              <a:t> (§13.2.3, Q = Ptest / (Fy Anetg) ≤ 1, interpolated between tmin and tmax)</a:t>
+              <a:t> (§13.2.3, Q = P</a:t>
+            </a:r>
+            <a:r>
+              <a:rPr baseline="-25000" b="0" sz="1600"/>
+              <a:t>test</a:t>
+            </a:r>
+            <a:r>
+              <a:rPr b="0" sz="1600"/>
+              <a:t> / (F</a:t>
+            </a:r>
+            <a:r>
+              <a:rPr baseline="-25000" b="0" sz="1600"/>
+              <a:t>y</a:t>
+            </a:r>
+            <a:r>
+              <a:rPr b="0" sz="1600"/>
+              <a:t> A</a:t>
+            </a:r>
+            <a:r>
+              <a:rPr baseline="-25000" b="0" sz="1600"/>
+              <a:t>netg</a:t>
+            </a:r>
+            <a:r>
+              <a:rPr b="0" sz="1600"/>
+              <a:t>) ≤ 1, interpolated between t</a:t>
+            </a:r>
+            <a:r>
+              <a:rPr baseline="-25000" b="0" sz="1600"/>
+              <a:t>min</a:t>
+            </a:r>
+            <a:r>
+              <a:rPr b="0" sz="1600"/>
+              <a:t> and t</a:t>
+            </a:r>
+            <a:r>
+              <a:rPr baseline="-25000" b="0" sz="1600"/>
+              <a:t>max</a:t>
+            </a:r>
+            <a:r>
+              <a:rPr b="0" sz="1600"/>
+              <a:t>)</a:t>
             </a:r>
           </a:p>
           <a:p>
@@ -5867,7 +7056,11 @@
             </a:pPr>
             <a:r>
               <a:rPr b="0" sz="1600"/>
-              <a:t>For a given Q, the new form is less severe at intermediate λc</a:t>
+              <a:t>For a given Q, the new form is less severe at intermediate λ</a:t>
+            </a:r>
+            <a:r>
+              <a:rPr baseline="-25000" b="0" sz="1600"/>
+              <a:t>c</a:t>
             </a:r>
           </a:p>
         </p:txBody>
@@ -5925,7 +7118,103 @@
                   <a:srgbClr val="4B5666"/>
                 </a:solidFill>
               </a:rPr>
-              <a:t>Both forms with Fn/Fy = Pne/Py on the same area basis. 2012 used Anet,min; 2021 uses Anetg from the strip section.</a:t>
+              <a:t>Both forms with F</a:t>
+            </a:r>
+            <a:r>
+              <a:rPr baseline="-25000" b="0" sz="1100">
+                <a:solidFill>
+                  <a:srgbClr val="4B5666"/>
+                </a:solidFill>
+              </a:rPr>
+              <a:t>n</a:t>
+            </a:r>
+            <a:r>
+              <a:rPr b="0" sz="1100">
+                <a:solidFill>
+                  <a:srgbClr val="4B5666"/>
+                </a:solidFill>
+              </a:rPr>
+              <a:t>/F</a:t>
+            </a:r>
+            <a:r>
+              <a:rPr baseline="-25000" b="0" sz="1100">
+                <a:solidFill>
+                  <a:srgbClr val="4B5666"/>
+                </a:solidFill>
+              </a:rPr>
+              <a:t>y</a:t>
+            </a:r>
+            <a:r>
+              <a:rPr b="0" sz="1100">
+                <a:solidFill>
+                  <a:srgbClr val="4B5666"/>
+                </a:solidFill>
+              </a:rPr>
+              <a:t> = P</a:t>
+            </a:r>
+            <a:r>
+              <a:rPr baseline="-25000" b="0" sz="1100">
+                <a:solidFill>
+                  <a:srgbClr val="4B5666"/>
+                </a:solidFill>
+              </a:rPr>
+              <a:t>ne</a:t>
+            </a:r>
+            <a:r>
+              <a:rPr b="0" sz="1100">
+                <a:solidFill>
+                  <a:srgbClr val="4B5666"/>
+                </a:solidFill>
+              </a:rPr>
+              <a:t>/P</a:t>
+            </a:r>
+            <a:r>
+              <a:rPr baseline="-25000" b="0" sz="1100">
+                <a:solidFill>
+                  <a:srgbClr val="4B5666"/>
+                </a:solidFill>
+              </a:rPr>
+              <a:t>y</a:t>
+            </a:r>
+            <a:r>
+              <a:rPr b="0" sz="1100">
+                <a:solidFill>
+                  <a:srgbClr val="4B5666"/>
+                </a:solidFill>
+              </a:rPr>
+              <a:t> on the same area basis. 2012 used A</a:t>
+            </a:r>
+            <a:r>
+              <a:rPr baseline="-25000" b="0" sz="1100">
+                <a:solidFill>
+                  <a:srgbClr val="4B5666"/>
+                </a:solidFill>
+              </a:rPr>
+              <a:t>net,min</a:t>
+            </a:r>
+            <a:r>
+              <a:rPr b="0" sz="1100">
+                <a:solidFill>
+                  <a:srgbClr val="4B5666"/>
+                </a:solidFill>
+              </a:rPr>
+              <a:t>; 2021 uses A</a:t>
+            </a:r>
+            <a:r>
+              <a:rPr baseline="-25000" b="0" sz="1100">
+                <a:solidFill>
+                  <a:srgbClr val="4B5666"/>
+                </a:solidFill>
+              </a:rPr>
+              <a:t>netg</a:t>
+            </a:r>
+            <a:r>
+              <a:rPr b="0" sz="1100">
+                <a:solidFill>
+                  <a:srgbClr val="4B5666"/>
+                </a:solidFill>
+              </a:rPr>
+              <a:t> from the strip section.</a:t>
             </a:r>
           </a:p>
         </p:txBody>
@@ -6052,7 +7341,23 @@
             </a:pPr>
             <a:r>
               <a:rPr b="0" sz="1600"/>
-              <a:t>New in 2021: an explicit distortional check with an elastic buckling load, Pcrd or Mcrd, the DSM ingredient</a:t>
+              <a:t>New in 2021: an explicit distortional check with an elastic buckling load, P</a:t>
+            </a:r>
+            <a:r>
+              <a:rPr baseline="-25000" b="0" sz="1600"/>
+              <a:t>crd</a:t>
+            </a:r>
+            <a:r>
+              <a:rPr b="0" sz="1600"/>
+              <a:t> or M</a:t>
+            </a:r>
+            <a:r>
+              <a:rPr baseline="-25000" b="0" sz="1600"/>
+              <a:t>crd</a:t>
+            </a:r>
+            <a:r>
+              <a:rPr b="0" sz="1600"/>
+              <a:t>, the DSM ingredient</a:t>
             </a:r>
           </a:p>
           <a:p>
@@ -6067,7 +7372,19 @@
             </a:r>
             <a:r>
               <a:rPr b="1" sz="1600"/>
-              <a:t>anchored at Pne instead of Py</a:t>
+              <a:t>anchored at P</a:t>
+            </a:r>
+            <a:r>
+              <a:rPr baseline="-25000" b="1" sz="1600"/>
+              <a:t>ne</a:t>
+            </a:r>
+            <a:r>
+              <a:rPr b="1" sz="1600"/>
+              <a:t> instead of P</a:t>
+            </a:r>
+            <a:r>
+              <a:rPr baseline="-25000" b="1" sz="1600"/>
+              <a:t>y</a:t>
             </a:r>
           </a:p>
           <a:p>
@@ -6089,7 +7406,23 @@
             </a:pPr>
             <a:r>
               <a:rPr b="0" sz="1600"/>
-              <a:t>At λc = 0 the two agree; at intermediate slenderness MH16.1 is lower, and both reach Pne for slender columns</a:t>
+              <a:t>At λ</a:t>
+            </a:r>
+            <a:r>
+              <a:rPr baseline="-25000" b="0" sz="1600"/>
+              <a:t>c</a:t>
+            </a:r>
+            <a:r>
+              <a:rPr b="0" sz="1600"/>
+              <a:t> = 0 the two agree; at intermediate slenderness MH16.1 is lower, and both reach P</a:t>
+            </a:r>
+            <a:r>
+              <a:rPr baseline="-25000" b="0" sz="1600"/>
+              <a:t>ne</a:t>
+            </a:r>
+            <a:r>
+              <a:rPr b="0" sz="1600"/>
+              <a:t> for slender columns</a:t>
             </a:r>
           </a:p>
         </p:txBody>
@@ -6147,7 +7480,31 @@
                   <a:srgbClr val="4B5666"/>
                 </a:solidFill>
               </a:rPr>
-              <a:t>Example with Pcrd = 0.6 Py</a:t>
+              <a:t>Example with P</a:t>
+            </a:r>
+            <a:r>
+              <a:rPr baseline="-25000" b="0" sz="1100">
+                <a:solidFill>
+                  <a:srgbClr val="4B5666"/>
+                </a:solidFill>
+              </a:rPr>
+              <a:t>crd</a:t>
+            </a:r>
+            <a:r>
+              <a:rPr b="0" sz="1100">
+                <a:solidFill>
+                  <a:srgbClr val="4B5666"/>
+                </a:solidFill>
+              </a:rPr>
+              <a:t> = 0.6 P</a:t>
+            </a:r>
+            <a:r>
+              <a:rPr baseline="-25000" b="0" sz="1100">
+                <a:solidFill>
+                  <a:srgbClr val="4B5666"/>
+                </a:solidFill>
+              </a:rPr>
+              <a:t>y</a:t>
             </a:r>
           </a:p>
         </p:txBody>
@@ -6296,7 +7653,15 @@
             </a:pPr>
             <a:r>
               <a:rPr b="0" sz="1400"/>
-              <a:t>build the round-corner section with td in the perforated strips</a:t>
+              <a:t>build the round-corner section with t</a:t>
+            </a:r>
+            <a:r>
+              <a:rPr baseline="-25000" b="0" sz="1400"/>
+              <a:t>d</a:t>
+            </a:r>
+            <a:r>
+              <a:rPr b="0" sz="1400"/>
+              <a:t> in the perforated strips</a:t>
             </a:r>
           </a:p>
           <a:p>
@@ -6318,7 +7683,15 @@
             </a:pPr>
             <a:r>
               <a:rPr b="0" sz="1400"/>
-              <a:t>read Pcrd at the distortional minimum</a:t>
+              <a:t>read P</a:t>
+            </a:r>
+            <a:r>
+              <a:rPr baseline="-25000" b="0" sz="1400"/>
+              <a:t>crd</a:t>
+            </a:r>
+            <a:r>
+              <a:rPr b="0" sz="1400"/>
+              <a:t> at the distortional minimum</a:t>
             </a:r>
           </a:p>
           <a:p>
@@ -6329,7 +7702,15 @@
             </a:pPr>
             <a:r>
               <a:rPr b="0" sz="1400"/>
-              <a:t>the same model with tg gives the global section properties</a:t>
+              <a:t>the same model with t</a:t>
+            </a:r>
+            <a:r>
+              <a:rPr baseline="-25000" b="0" sz="1400"/>
+              <a:t>g</a:t>
+            </a:r>
+            <a:r>
+              <a:rPr b="0" sz="1400"/>
+              <a:t> gives the global section properties</a:t>
             </a:r>
           </a:p>
           <a:p>
@@ -6512,7 +7893,7 @@
         <p:spPr>
           <a:xfrm>
             <a:off x="838200" y="1825625"/>
-            <a:ext cx="5181600" cy="1737360"/>
+            <a:ext cx="5181600" cy="1914842"/>
           </a:xfrm>
           <a:prstGeom prst="rect">
             <a:avLst/>
@@ -6542,14 +7923,35 @@
           </a:fontRef>
         </p:style>
         <p:txBody>
-          <a:bodyPr rtlCol="0" anchor="t" wrap="square" lIns="137160" rIns="137160" tIns="73152"/>
-          <a:lstStyle/>
-          <a:p>
-            <a:pPr algn="ctr">
-              <a:spcAft>
-                <a:spcPts val="600"/>
-              </a:spcAft>
-            </a:pPr>
+          <a:bodyPr rtlCol="0" anchor="ctr"/>
+          <a:lstStyle/>
+          <a:p>
+            <a:pPr algn="ctr"/>
+          </a:p>
+        </p:txBody>
+      </p:sp>
+      <p:sp>
+        <p:nvSpPr>
+          <p:cNvPr id="4" name="TextBox 3"/>
+          <p:cNvSpPr txBox="1"/>
+          <p:nvPr/>
+        </p:nvSpPr>
+        <p:spPr>
+          <a:xfrm>
+            <a:off x="883920" y="1880489"/>
+            <a:ext cx="5181600" cy="320040"/>
+          </a:xfrm>
+          <a:prstGeom prst="rect">
+            <a:avLst/>
+          </a:prstGeom>
+          <a:noFill/>
+        </p:spPr>
+        <p:txBody>
+          <a:bodyPr wrap="none">
+            <a:spAutoFit/>
+          </a:bodyPr>
+          <a:lstStyle/>
+          <a:p>
             <a:r>
               <a:rPr b="1" sz="1400">
                 <a:solidFill>
@@ -6559,48 +7961,139 @@
               <a:t>Local + global (8.2-9, 8.2-10)</a:t>
             </a:r>
           </a:p>
-          <a:p>
-            <a:pPr>
-              <a:spcAft>
-                <a:spcPts val="400"/>
-              </a:spcAft>
-            </a:pPr>
+        </p:txBody>
+      </p:sp>
+      <p:pic>
+        <p:nvPicPr>
+          <p:cNvPr id="5" name="Picture 4" descr="mnlg.png"/>
+          <p:cNvPicPr>
+            <a:picLocks noChangeAspect="1"/>
+          </p:cNvPicPr>
+          <p:nvPr/>
+        </p:nvPicPr>
+        <p:blipFill>
+          <a:blip r:embed="rId2"/>
+          <a:stretch>
+            <a:fillRect/>
+          </a:stretch>
+        </p:blipFill>
+        <p:spPr>
+          <a:xfrm>
+            <a:off x="1021080" y="2301113"/>
+            <a:ext cx="4815840" cy="790130"/>
+          </a:xfrm>
+          <a:prstGeom prst="rect">
+            <a:avLst/>
+          </a:prstGeom>
+        </p:spPr>
+      </p:pic>
+      <p:sp>
+        <p:nvSpPr>
+          <p:cNvPr id="6" name="TextBox 5"/>
+          <p:cNvSpPr txBox="1"/>
+          <p:nvPr/>
+        </p:nvSpPr>
+        <p:spPr>
+          <a:xfrm>
+            <a:off x="883920" y="3164395"/>
+            <a:ext cx="5090160" cy="457200"/>
+          </a:xfrm>
+          <a:prstGeom prst="rect">
+            <a:avLst/>
+          </a:prstGeom>
+          <a:noFill/>
+        </p:spPr>
+        <p:txBody>
+          <a:bodyPr wrap="square" tIns="0" bIns="0">
+            <a:spAutoFit/>
+          </a:bodyPr>
+          <a:lstStyle/>
+          <a:p>
             <a:r>
               <a:rPr b="0" sz="1500">
                 <a:solidFill>
                   <a:srgbClr val="2B3648"/>
                 </a:solidFill>
               </a:rPr>
-              <a:t>Mnlg = Mne [1 − ½ (1 − Q)(Mne / My)^(Q/(1−Q))],  Q &lt; 1</a:t>
-            </a:r>
-          </a:p>
-          <a:p>
-            <a:pPr>
-              <a:spcAft>
-                <a:spcPts val="400"/>
-              </a:spcAft>
-            </a:pPr>
+              <a:t>M</a:t>
+            </a:r>
+            <a:r>
+              <a:rPr baseline="-25000" b="0" sz="1500">
+                <a:solidFill>
+                  <a:srgbClr val="2B3648"/>
+                </a:solidFill>
+              </a:rPr>
+              <a:t>y</a:t>
+            </a:r>
             <a:r>
               <a:rPr b="0" sz="1500">
                 <a:solidFill>
                   <a:srgbClr val="2B3648"/>
                 </a:solidFill>
               </a:rPr>
-              <a:t>My = Fy Sfy, with Sfy on the reduced-thickness section</a:t>
-            </a:r>
-          </a:p>
-        </p:txBody>
-      </p:sp>
-      <p:sp>
-        <p:nvSpPr>
-          <p:cNvPr id="4" name="Rectangle 3"/>
+              <a:t> = F</a:t>
+            </a:r>
+            <a:r>
+              <a:rPr baseline="-25000" b="0" sz="1500">
+                <a:solidFill>
+                  <a:srgbClr val="2B3648"/>
+                </a:solidFill>
+              </a:rPr>
+              <a:t>y</a:t>
+            </a:r>
+            <a:r>
+              <a:rPr b="0" sz="1500">
+                <a:solidFill>
+                  <a:srgbClr val="2B3648"/>
+                </a:solidFill>
+              </a:rPr>
+              <a:t> S</a:t>
+            </a:r>
+            <a:r>
+              <a:rPr baseline="-25000" b="0" sz="1500">
+                <a:solidFill>
+                  <a:srgbClr val="2B3648"/>
+                </a:solidFill>
+              </a:rPr>
+              <a:t>fy</a:t>
+            </a:r>
+            <a:r>
+              <a:rPr b="0" sz="1500">
+                <a:solidFill>
+                  <a:srgbClr val="2B3648"/>
+                </a:solidFill>
+              </a:rPr>
+              <a:t>, with S</a:t>
+            </a:r>
+            <a:r>
+              <a:rPr baseline="-25000" b="0" sz="1500">
+                <a:solidFill>
+                  <a:srgbClr val="2B3648"/>
+                </a:solidFill>
+              </a:rPr>
+              <a:t>fy</a:t>
+            </a:r>
+            <a:r>
+              <a:rPr b="0" sz="1500">
+                <a:solidFill>
+                  <a:srgbClr val="2B3648"/>
+                </a:solidFill>
+              </a:rPr>
+              <a:t> on the reduced-thickness section</a:t>
+            </a:r>
+          </a:p>
+        </p:txBody>
+      </p:sp>
+      <p:sp>
+        <p:nvSpPr>
+          <p:cNvPr id="7" name="Rectangle 6"/>
           <p:cNvSpPr/>
           <p:nvPr/>
         </p:nvSpPr>
         <p:spPr>
           <a:xfrm>
             <a:off x="6172200" y="1825625"/>
-            <a:ext cx="5181600" cy="1737360"/>
+            <a:ext cx="5181600" cy="1728606"/>
           </a:xfrm>
           <a:prstGeom prst="rect">
             <a:avLst/>
@@ -6630,65 +8123,23 @@
           </a:fontRef>
         </p:style>
         <p:txBody>
-          <a:bodyPr rtlCol="0" anchor="t" wrap="square" lIns="137160" rIns="137160" tIns="73152"/>
-          <a:lstStyle/>
-          <a:p>
-            <a:pPr algn="ctr">
-              <a:spcAft>
-                <a:spcPts val="600"/>
-              </a:spcAft>
-            </a:pPr>
-            <a:r>
-              <a:rPr b="1" sz="1400">
-                <a:solidFill>
-                  <a:srgbClr val="0E2841"/>
-                </a:solidFill>
-              </a:rPr>
-              <a:t>Distortional + global (8.2-11, 8.2-12)</a:t>
-            </a:r>
-          </a:p>
-          <a:p>
-            <a:pPr>
-              <a:spcAft>
-                <a:spcPts val="400"/>
-              </a:spcAft>
-            </a:pPr>
-            <a:r>
-              <a:rPr b="0" sz="1500">
-                <a:solidFill>
-                  <a:srgbClr val="2B3648"/>
-                </a:solidFill>
-              </a:rPr>
-              <a:t>Mnld = [1 − 0.22 (Mcrd / Mne)^0.5] (Mcrd / Mne)^0.5 · Mne</a:t>
-            </a:r>
-          </a:p>
-          <a:p>
-            <a:pPr>
-              <a:spcAft>
-                <a:spcPts val="400"/>
-              </a:spcAft>
-            </a:pPr>
-            <a:r>
-              <a:rPr b="0" sz="1500">
-                <a:solidFill>
-                  <a:srgbClr val="2B3648"/>
-                </a:solidFill>
-              </a:rPr>
-              <a:t>for λd = √(Mne / Mcrd) &gt; 0.673, else Mnld = Mne</a:t>
-            </a:r>
-          </a:p>
-        </p:txBody>
-      </p:sp>
-      <p:sp>
-        <p:nvSpPr>
-          <p:cNvPr id="5" name="TextBox 4"/>
+          <a:bodyPr rtlCol="0" anchor="ctr"/>
+          <a:lstStyle/>
+          <a:p>
+            <a:pPr algn="ctr"/>
+          </a:p>
+        </p:txBody>
+      </p:sp>
+      <p:sp>
+        <p:nvSpPr>
+          <p:cNvPr id="8" name="TextBox 7"/>
           <p:cNvSpPr txBox="1"/>
           <p:nvPr/>
         </p:nvSpPr>
         <p:spPr>
           <a:xfrm>
-            <a:off x="838200" y="3837305"/>
-            <a:ext cx="10515600" cy="1828800"/>
+            <a:off x="6217920" y="1880489"/>
+            <a:ext cx="5181600" cy="320040"/>
           </a:xfrm>
           <a:prstGeom prst="rect">
             <a:avLst/>
@@ -6696,41 +8147,358 @@
           <a:noFill/>
         </p:spPr>
         <p:txBody>
-          <a:bodyPr wrap="square">
+          <a:bodyPr wrap="none">
             <a:spAutoFit/>
           </a:bodyPr>
           <a:lstStyle/>
           <a:p>
-            <a:pPr>
-              <a:spcAft>
-                <a:spcPts val="400"/>
-              </a:spcAft>
-            </a:pPr>
-            <a:r>
-              <a:rPr b="0" sz="1600"/>
-              <a:t>•  Mn = min(Mnlg, Mnld) for open cold-formed sections bending about the axis of symmetry; hot-rolled and closed sections use Mnlg</a:t>
-            </a:r>
-          </a:p>
-          <a:p>
-            <a:pPr>
-              <a:spcAft>
-                <a:spcPts val="400"/>
-              </a:spcAft>
-            </a:pPr>
-            <a:r>
-              <a:rPr b="0" sz="1600"/>
-              <a:t>•  The coefficients match the AISI S100 flexural distortional curve, anchored at Mne like compression</a:t>
-            </a:r>
-          </a:p>
-          <a:p>
-            <a:pPr>
-              <a:spcAft>
-                <a:spcPts val="400"/>
-              </a:spcAft>
-            </a:pPr>
-            <a:r>
-              <a:rPr b="0" sz="1600"/>
-              <a:t>•  Mcrd comes from finite strip analysis on the td section, as for Pcrd</a:t>
+            <a:r>
+              <a:rPr b="1" sz="1400">
+                <a:solidFill>
+                  <a:srgbClr val="0E2841"/>
+                </a:solidFill>
+              </a:rPr>
+              <a:t>Distortional + global (8.2-11, 8.2-12)</a:t>
+            </a:r>
+          </a:p>
+        </p:txBody>
+      </p:sp>
+      <p:pic>
+        <p:nvPicPr>
+          <p:cNvPr id="9" name="Picture 8" descr="mnld.png"/>
+          <p:cNvPicPr>
+            <a:picLocks noChangeAspect="1"/>
+          </p:cNvPicPr>
+          <p:nvPr/>
+        </p:nvPicPr>
+        <p:blipFill>
+          <a:blip r:embed="rId3"/>
+          <a:stretch>
+            <a:fillRect/>
+          </a:stretch>
+        </p:blipFill>
+        <p:spPr>
+          <a:xfrm>
+            <a:off x="6355080" y="2301113"/>
+            <a:ext cx="4815840" cy="832494"/>
+          </a:xfrm>
+          <a:prstGeom prst="rect">
+            <a:avLst/>
+          </a:prstGeom>
+        </p:spPr>
+      </p:pic>
+      <p:sp>
+        <p:nvSpPr>
+          <p:cNvPr id="10" name="TextBox 9"/>
+          <p:cNvSpPr txBox="1"/>
+          <p:nvPr/>
+        </p:nvSpPr>
+        <p:spPr>
+          <a:xfrm>
+            <a:off x="6217920" y="3206759"/>
+            <a:ext cx="5090160" cy="228600"/>
+          </a:xfrm>
+          <a:prstGeom prst="rect">
+            <a:avLst/>
+          </a:prstGeom>
+          <a:noFill/>
+        </p:spPr>
+        <p:txBody>
+          <a:bodyPr wrap="square" tIns="0" bIns="0">
+            <a:spAutoFit/>
+          </a:bodyPr>
+          <a:lstStyle/>
+          <a:p>
+            <a:r>
+              <a:rPr b="0" sz="1500">
+                <a:solidFill>
+                  <a:srgbClr val="2B3648"/>
+                </a:solidFill>
+              </a:rPr>
+              <a:t>for λ</a:t>
+            </a:r>
+            <a:r>
+              <a:rPr baseline="-25000" b="0" sz="1500">
+                <a:solidFill>
+                  <a:srgbClr val="2B3648"/>
+                </a:solidFill>
+              </a:rPr>
+              <a:t>d</a:t>
+            </a:r>
+            <a:r>
+              <a:rPr b="0" sz="1500">
+                <a:solidFill>
+                  <a:srgbClr val="2B3648"/>
+                </a:solidFill>
+              </a:rPr>
+              <a:t> = √(M</a:t>
+            </a:r>
+            <a:r>
+              <a:rPr baseline="-25000" b="0" sz="1500">
+                <a:solidFill>
+                  <a:srgbClr val="2B3648"/>
+                </a:solidFill>
+              </a:rPr>
+              <a:t>ne</a:t>
+            </a:r>
+            <a:r>
+              <a:rPr b="0" sz="1500">
+                <a:solidFill>
+                  <a:srgbClr val="2B3648"/>
+                </a:solidFill>
+              </a:rPr>
+              <a:t> / M</a:t>
+            </a:r>
+            <a:r>
+              <a:rPr baseline="-25000" b="0" sz="1500">
+                <a:solidFill>
+                  <a:srgbClr val="2B3648"/>
+                </a:solidFill>
+              </a:rPr>
+              <a:t>crd</a:t>
+            </a:r>
+            <a:r>
+              <a:rPr b="0" sz="1500">
+                <a:solidFill>
+                  <a:srgbClr val="2B3648"/>
+                </a:solidFill>
+              </a:rPr>
+              <a:t>) &gt; 0.673, else M</a:t>
+            </a:r>
+            <a:r>
+              <a:rPr baseline="-25000" b="0" sz="1500">
+                <a:solidFill>
+                  <a:srgbClr val="2B3648"/>
+                </a:solidFill>
+              </a:rPr>
+              <a:t>nld</a:t>
+            </a:r>
+            <a:r>
+              <a:rPr b="0" sz="1500">
+                <a:solidFill>
+                  <a:srgbClr val="2B3648"/>
+                </a:solidFill>
+              </a:rPr>
+              <a:t> = M</a:t>
+            </a:r>
+            <a:r>
+              <a:rPr baseline="-25000" b="0" sz="1500">
+                <a:solidFill>
+                  <a:srgbClr val="2B3648"/>
+                </a:solidFill>
+              </a:rPr>
+              <a:t>ne</a:t>
+            </a:r>
+          </a:p>
+        </p:txBody>
+      </p:sp>
+      <p:sp>
+        <p:nvSpPr>
+          <p:cNvPr id="11" name="TextBox 10"/>
+          <p:cNvSpPr txBox="1"/>
+          <p:nvPr/>
+        </p:nvSpPr>
+        <p:spPr>
+          <a:xfrm>
+            <a:off x="838200" y="4014787"/>
+            <a:ext cx="10515600" cy="487680"/>
+          </a:xfrm>
+          <a:prstGeom prst="rect">
+            <a:avLst/>
+          </a:prstGeom>
+          <a:noFill/>
+        </p:spPr>
+        <p:txBody>
+          <a:bodyPr wrap="square" tIns="0" bIns="0">
+            <a:spAutoFit/>
+          </a:bodyPr>
+          <a:lstStyle/>
+          <a:p>
+            <a:r>
+              <a:rPr b="0" sz="1600">
+                <a:solidFill>
+                  <a:srgbClr val="0E2841"/>
+                </a:solidFill>
+              </a:rPr>
+              <a:t>•  M</a:t>
+            </a:r>
+            <a:r>
+              <a:rPr baseline="-25000" b="0" sz="1600">
+                <a:solidFill>
+                  <a:srgbClr val="0E2841"/>
+                </a:solidFill>
+              </a:rPr>
+              <a:t>n</a:t>
+            </a:r>
+            <a:r>
+              <a:rPr b="0" sz="1600">
+                <a:solidFill>
+                  <a:srgbClr val="0E2841"/>
+                </a:solidFill>
+              </a:rPr>
+              <a:t> = min(M</a:t>
+            </a:r>
+            <a:r>
+              <a:rPr baseline="-25000" b="0" sz="1600">
+                <a:solidFill>
+                  <a:srgbClr val="0E2841"/>
+                </a:solidFill>
+              </a:rPr>
+              <a:t>nlg</a:t>
+            </a:r>
+            <a:r>
+              <a:rPr b="0" sz="1600">
+                <a:solidFill>
+                  <a:srgbClr val="0E2841"/>
+                </a:solidFill>
+              </a:rPr>
+              <a:t>, M</a:t>
+            </a:r>
+            <a:r>
+              <a:rPr baseline="-25000" b="0" sz="1600">
+                <a:solidFill>
+                  <a:srgbClr val="0E2841"/>
+                </a:solidFill>
+              </a:rPr>
+              <a:t>nld</a:t>
+            </a:r>
+            <a:r>
+              <a:rPr b="0" sz="1600">
+                <a:solidFill>
+                  <a:srgbClr val="0E2841"/>
+                </a:solidFill>
+              </a:rPr>
+              <a:t>) for open cold-formed sections bending about the axis of symmetry; hot-rolled and closed sections use M</a:t>
+            </a:r>
+            <a:r>
+              <a:rPr baseline="-25000" b="0" sz="1600">
+                <a:solidFill>
+                  <a:srgbClr val="0E2841"/>
+                </a:solidFill>
+              </a:rPr>
+              <a:t>nlg</a:t>
+            </a:r>
+          </a:p>
+        </p:txBody>
+      </p:sp>
+      <p:sp>
+        <p:nvSpPr>
+          <p:cNvPr id="12" name="TextBox 11"/>
+          <p:cNvSpPr txBox="1"/>
+          <p:nvPr/>
+        </p:nvSpPr>
+        <p:spPr>
+          <a:xfrm>
+            <a:off x="838200" y="4575619"/>
+            <a:ext cx="10515600" cy="243840"/>
+          </a:xfrm>
+          <a:prstGeom prst="rect">
+            <a:avLst/>
+          </a:prstGeom>
+          <a:noFill/>
+        </p:spPr>
+        <p:txBody>
+          <a:bodyPr wrap="square" tIns="0" bIns="0">
+            <a:spAutoFit/>
+          </a:bodyPr>
+          <a:lstStyle/>
+          <a:p>
+            <a:r>
+              <a:rPr b="0" sz="1600">
+                <a:solidFill>
+                  <a:srgbClr val="0E2841"/>
+                </a:solidFill>
+              </a:rPr>
+              <a:t>•  The coefficients match the AISI S100 flexural distortional curve, anchored at M</a:t>
+            </a:r>
+            <a:r>
+              <a:rPr baseline="-25000" b="0" sz="1600">
+                <a:solidFill>
+                  <a:srgbClr val="0E2841"/>
+                </a:solidFill>
+              </a:rPr>
+              <a:t>ne</a:t>
+            </a:r>
+            <a:r>
+              <a:rPr b="0" sz="1600">
+                <a:solidFill>
+                  <a:srgbClr val="0E2841"/>
+                </a:solidFill>
+              </a:rPr>
+              <a:t> like compression</a:t>
+            </a:r>
+          </a:p>
+        </p:txBody>
+      </p:sp>
+      <p:sp>
+        <p:nvSpPr>
+          <p:cNvPr id="13" name="TextBox 12"/>
+          <p:cNvSpPr txBox="1"/>
+          <p:nvPr/>
+        </p:nvSpPr>
+        <p:spPr>
+          <a:xfrm>
+            <a:off x="838200" y="4892611"/>
+            <a:ext cx="10515600" cy="243840"/>
+          </a:xfrm>
+          <a:prstGeom prst="rect">
+            <a:avLst/>
+          </a:prstGeom>
+          <a:noFill/>
+        </p:spPr>
+        <p:txBody>
+          <a:bodyPr wrap="square" tIns="0" bIns="0">
+            <a:spAutoFit/>
+          </a:bodyPr>
+          <a:lstStyle/>
+          <a:p>
+            <a:r>
+              <a:rPr b="0" sz="1600">
+                <a:solidFill>
+                  <a:srgbClr val="0E2841"/>
+                </a:solidFill>
+              </a:rPr>
+              <a:t>•  M</a:t>
+            </a:r>
+            <a:r>
+              <a:rPr baseline="-25000" b="0" sz="1600">
+                <a:solidFill>
+                  <a:srgbClr val="0E2841"/>
+                </a:solidFill>
+              </a:rPr>
+              <a:t>crd</a:t>
+            </a:r>
+            <a:r>
+              <a:rPr b="0" sz="1600">
+                <a:solidFill>
+                  <a:srgbClr val="0E2841"/>
+                </a:solidFill>
+              </a:rPr>
+              <a:t> comes from finite strip analysis on the t</a:t>
+            </a:r>
+            <a:r>
+              <a:rPr baseline="-25000" b="0" sz="1600">
+                <a:solidFill>
+                  <a:srgbClr val="0E2841"/>
+                </a:solidFill>
+              </a:rPr>
+              <a:t>d</a:t>
+            </a:r>
+            <a:r>
+              <a:rPr b="0" sz="1600">
+                <a:solidFill>
+                  <a:srgbClr val="0E2841"/>
+                </a:solidFill>
+              </a:rPr>
+              <a:t> section, as for P</a:t>
+            </a:r>
+            <a:r>
+              <a:rPr baseline="-25000" b="0" sz="1600">
+                <a:solidFill>
+                  <a:srgbClr val="0E2841"/>
+                </a:solidFill>
+              </a:rPr>
+              <a:t>crd</a:t>
             </a:r>
           </a:p>
         </p:txBody>

</xml_diff>